<commit_message>
feat: add Product & Experience Design section (08)
New section covering industrial design, UX, HMI, and brand visual trends
in the semiconductor industry. Includes 5 verified findings:
- Cadence ChipStack AI Super Agent (agentic EDA UX)
- NVIDIA Vera Rubin (extreme codesign as industrial design)
- Siemens Digital Twin Composer (HMI → virtual twin)
- Intel 18A Core Ultra Series 3 launch
- NVIDIA + industrial software partnership

Renumbers subsequent sections (Policy 09, Landscape 10, Reading 11, Calendar 12).
Updates: data.mjs, index.html, PPT, Word, REPORT_GUIDE.md

Co-Authored-By: Claude Opus 4.6 (1M context) <noreply@anthropic.com>
</commit_message>
<xml_diff>
--- a/report-2026-W15.pptx
+++ b/report-2026-W15.pptx
@@ -17,9 +17,10 @@
     <p:sldId id="265" r:id="rId11"/>
     <p:sldId id="266" r:id="rId12"/>
     <p:sldId id="267" r:id="rId13"/>
+    <p:sldId id="268" r:id="rId14"/>
   </p:sldIdLst>
   <p:notesMasterIdLst>
-    <p:notesMasterId r:id="rId14"/>
+    <p:notesMasterId r:id="rId15"/>
   </p:notesMasterIdLst>
   <p:sldSz cx="12188952" cy="6858000"/>
   <p:notesSz cx="6858000" cy="12188952"/>
@@ -801,6 +802,94 @@
             <a:fld id="{F7021451-1387-4CA6-816F-3879F97B5CBC}" type="slidenum">
               <a:rPr lang="en-US"/>
               <a:t>12</a:t>
+            </a:fld>
+            <a:endParaRPr lang="en-US"/>
+          </a:p>
+        </p:txBody>
+      </p:sp>
+    </p:spTree>
+    <p:extLst>
+      <p:ext uri="{BB962C8B-B14F-4D97-AF65-F5344CB8AC3E}">
+        <p14:creationId xmlns:p14="http://schemas.microsoft.com/office/powerpoint/2010/main" val="1024086991"/>
+      </p:ext>
+    </p:extLst>
+  </p:cSld>
+  <p:clrMapOvr>
+    <a:masterClrMapping/>
+  </p:clrMapOvr>
+</p:notes>
+</file>
+
+<file path=ppt/notesSlides/notesSlide13.xml><?xml version="1.0" encoding="utf-8"?>
+<p:notes xmlns:a="http://schemas.openxmlformats.org/drawingml/2006/main" xmlns:r="http://schemas.openxmlformats.org/officeDocument/2006/relationships" xmlns:p="http://schemas.openxmlformats.org/presentationml/2006/main">
+  <p:cSld>
+    <p:spTree>
+      <p:nvGrpSpPr>
+        <p:cNvPr id="1" name=""/>
+        <p:cNvGrpSpPr/>
+        <p:nvPr/>
+      </p:nvGrpSpPr>
+      <p:grpSpPr>
+        <a:xfrm>
+          <a:off x="0" y="0"/>
+          <a:ext cx="0" cy="0"/>
+          <a:chOff x="0" y="0"/>
+          <a:chExt cx="0" cy="0"/>
+        </a:xfrm>
+      </p:grpSpPr>
+      <p:sp>
+        <p:nvSpPr>
+          <p:cNvPr id="2" name="Slide Image Placeholder 1"/>
+          <p:cNvSpPr>
+            <a:spLocks noGrp="1" noRot="1" noChangeAspect="1"/>
+          </p:cNvSpPr>
+          <p:nvPr>
+            <p:ph type="sldImg"/>
+          </p:nvPr>
+        </p:nvSpPr>
+        <p:spPr/>
+      </p:sp>
+      <p:sp>
+        <p:nvSpPr>
+          <p:cNvPr id="3" name="Notes Placeholder 2"/>
+          <p:cNvSpPr>
+            <a:spLocks noGrp="1"/>
+          </p:cNvSpPr>
+          <p:nvPr>
+            <p:ph type="body" idx="1"/>
+          </p:nvPr>
+        </p:nvSpPr>
+        <p:spPr/>
+        <p:txBody>
+          <a:bodyPr/>
+          <a:lstStyle/>
+          <a:p>
+            <a:r>
+              <a:rPr lang="en-US" dirty="0"/>
+              <a:t/>
+            </a:r>
+            <a:endParaRPr lang="en-US" dirty="0"/>
+          </a:p>
+        </p:txBody>
+      </p:sp>
+      <p:sp>
+        <p:nvSpPr>
+          <p:cNvPr id="4" name="Slide Number Placeholder 3"/>
+          <p:cNvSpPr>
+            <a:spLocks noGrp="1"/>
+          </p:cNvSpPr>
+          <p:nvPr>
+            <p:ph type="sldNum" sz="quarter" idx="10"/>
+          </p:nvPr>
+        </p:nvSpPr>
+        <p:spPr/>
+        <p:txBody>
+          <a:bodyPr/>
+          <a:lstStyle/>
+          <a:p>
+            <a:fld id="{F7021451-1387-4CA6-816F-3879F97B5CBC}" type="slidenum">
+              <a:rPr lang="en-US"/>
+              <a:t>13</a:t>
             </a:fld>
             <a:endParaRPr lang="en-US"/>
           </a:p>
@@ -2475,7 +2564,7 @@
                 <a:ea typeface="JetBrains Mono" pitchFamily="34" charset="-122"/>
                 <a:cs typeface="JetBrains Mono" pitchFamily="34" charset="-120"/>
               </a:rPr>
-              <a:t>10 / 12</a:t>
+              <a:t>10 / 13</a:t>
             </a:r>
             <a:endParaRPr lang="en-US" sz="650" dirty="0"/>
           </a:p>
@@ -2553,7 +2642,7 @@
                 <a:ea typeface="HarmonyOS Sans SC" pitchFamily="34" charset="-122"/>
                 <a:cs typeface="HarmonyOS Sans SC" pitchFamily="34" charset="-120"/>
               </a:rPr>
-              <a:t>政策与地缘</a:t>
+              <a:t>产品与体验设计</a:t>
             </a:r>
             <a:endParaRPr lang="en-US" sz="2200" dirty="0"/>
           </a:p>
@@ -2592,7 +2681,7 @@
                 <a:ea typeface="JetBrains Mono" pitchFamily="34" charset="-122"/>
                 <a:cs typeface="JetBrains Mono" pitchFamily="34" charset="-120"/>
               </a:rPr>
-              <a:t>POLICY &amp; GEOPOLITICS</a:t>
+              <a:t>PRODUCT &amp; EXPERIENCE DESIGN</a:t>
             </a:r>
             <a:endParaRPr lang="en-US" sz="700" dirty="0"/>
           </a:p>
@@ -2600,74 +2689,13 @@
       </p:sp>
       <p:sp>
         <p:nvSpPr>
-          <p:cNvPr id="11" name="Shape 9"/>
+          <p:cNvPr id="11" name="Text 9"/>
           <p:cNvSpPr/>
           <p:nvPr/>
         </p:nvSpPr>
         <p:spPr>
           <a:xfrm>
             <a:off x="731520" y="1417320"/>
-            <a:ext cx="914400" cy="182880"/>
-          </a:xfrm>
-          <a:prstGeom prst="rect">
-            <a:avLst>
-              <a:gd name="adj" fmla="val 10000"/>
-            </a:avLst>
-          </a:prstGeom>
-          <a:solidFill>
-            <a:srgbClr val="F5F5F3"/>
-          </a:solidFill>
-          <a:ln/>
-        </p:spPr>
-      </p:sp>
-      <p:sp>
-        <p:nvSpPr>
-          <p:cNvPr id="12" name="Text 10"/>
-          <p:cNvSpPr/>
-          <p:nvPr/>
-        </p:nvSpPr>
-        <p:spPr>
-          <a:xfrm>
-            <a:off x="777240" y="1417320"/>
-            <a:ext cx="822960" cy="182880"/>
-          </a:xfrm>
-          <a:prstGeom prst="rect">
-            <a:avLst/>
-          </a:prstGeom>
-          <a:noFill/>
-          <a:ln/>
-        </p:spPr>
-        <p:txBody>
-          <a:bodyPr wrap="square" rtlCol="0" anchor="ctr"/>
-          <a:lstStyle/>
-          <a:p>
-            <a:pPr algn="ctr" indent="0" marL="0">
-              <a:buNone/>
-            </a:pPr>
-            <a:r>
-              <a:rPr lang="en-US" sz="650" dirty="0">
-                <a:solidFill>
-                  <a:srgbClr val="666666"/>
-                </a:solidFill>
-                <a:latin typeface="JetBrains Mono" pitchFamily="34" charset="0"/>
-                <a:ea typeface="JetBrains Mono" pitchFamily="34" charset="-122"/>
-                <a:cs typeface="JetBrains Mono" pitchFamily="34" charset="-120"/>
-              </a:rPr>
-              <a:t>U.S. CONGRESS</a:t>
-            </a:r>
-            <a:endParaRPr lang="en-US" sz="650" dirty="0"/>
-          </a:p>
-        </p:txBody>
-      </p:sp>
-      <p:sp>
-        <p:nvSpPr>
-          <p:cNvPr id="13" name="Text 11"/>
-          <p:cNvSpPr/>
-          <p:nvPr/>
-        </p:nvSpPr>
-        <p:spPr>
-          <a:xfrm>
-            <a:off x="731520" y="1673352"/>
             <a:ext cx="10725912" cy="228600"/>
           </a:xfrm>
           <a:prstGeom prst="rect">
@@ -2684,7 +2712,7 @@
               <a:buNone/>
             </a:pPr>
             <a:r>
-              <a:rPr lang="en-US" sz="1300" b="1" dirty="0">
+              <a:rPr lang="en-US" sz="1200" b="1" dirty="0">
                 <a:solidFill>
                   <a:srgbClr val="1A1A1A"/>
                 </a:solidFill>
@@ -2692,22 +2720,22 @@
                 <a:ea typeface="HarmonyOS Sans SC" pitchFamily="34" charset="-122"/>
                 <a:cs typeface="HarmonyOS Sans SC" pitchFamily="34" charset="-120"/>
               </a:rPr>
-              <a:t>MATCH Act：封堵 DUV 对华出口</a:t>
-            </a:r>
-            <a:endParaRPr lang="en-US" sz="1300" dirty="0"/>
-          </a:p>
-        </p:txBody>
-      </p:sp>
-      <p:sp>
-        <p:nvSpPr>
-          <p:cNvPr id="14" name="Text 12"/>
-          <p:cNvSpPr/>
-          <p:nvPr/>
-        </p:nvSpPr>
-        <p:spPr>
-          <a:xfrm>
-            <a:off x="731520" y="1920240"/>
-            <a:ext cx="10725912" cy="548640"/>
+              <a:t>Cadence ChipStack AI Super Agent：EDA 从菜单交互走向意图对话</a:t>
+            </a:r>
+            <a:endParaRPr lang="en-US" sz="1200" dirty="0"/>
+          </a:p>
+        </p:txBody>
+      </p:sp>
+      <p:sp>
+        <p:nvSpPr>
+          <p:cNvPr id="12" name="Text 10"/>
+          <p:cNvSpPr/>
+          <p:nvPr/>
+        </p:nvSpPr>
+        <p:spPr>
+          <a:xfrm>
+            <a:off x="731520" y="1673352"/>
+            <a:ext cx="10725912" cy="502920"/>
           </a:xfrm>
           <a:prstGeom prst="rect">
             <a:avLst/>
@@ -2734,7 +2762,7 @@
                 <a:ea typeface="HarmonyOS Sans SC" pitchFamily="34" charset="-122"/>
                 <a:cs typeface="HarmonyOS Sans SC" pitchFamily="34" charset="-120"/>
               </a:rPr>
-              <a:t>4 月 2 日众议院推出 MATCH Act，目标收紧 ASML DUV 光刻机对华出口，施压荷兰、日本盟友全面对齐美国管制标准。JPMorgan 估计若实施，ASML EPS 可能下降 10%。</a:t>
+              <a:t>Cadence 发布 ChipStack AI Super Agent（2 月 10 日），让工程师用自然语言描述意图，由多智能体自动生成 RTL、测试平台和验证方案。早期客户 NVIDIA、Qualcomm、Altera、Tenstorrent 反馈生产力提升 10x。这是 EDA 工具 UX 从"工具操作"到"意图对话"的历史性转向。</a:t>
             </a:r>
             <a:endParaRPr lang="en-US" sz="1000" dirty="0"/>
           </a:p>
@@ -2742,13 +2770,13 @@
       </p:sp>
       <p:sp>
         <p:nvSpPr>
-          <p:cNvPr id="15" name="Shape 13"/>
-          <p:cNvSpPr/>
-          <p:nvPr/>
-        </p:nvSpPr>
-        <p:spPr>
-          <a:xfrm>
-            <a:off x="731520" y="2651760"/>
+          <p:cNvPr id="13" name="Shape 11"/>
+          <p:cNvSpPr/>
+          <p:nvPr/>
+        </p:nvSpPr>
+        <p:spPr>
+          <a:xfrm>
+            <a:off x="731520" y="2331720"/>
             <a:ext cx="10725912" cy="0"/>
           </a:xfrm>
           <a:prstGeom prst="line">
@@ -2765,74 +2793,13 @@
       </p:sp>
       <p:sp>
         <p:nvSpPr>
-          <p:cNvPr id="16" name="Shape 14"/>
-          <p:cNvSpPr/>
-          <p:nvPr/>
-        </p:nvSpPr>
-        <p:spPr>
-          <a:xfrm>
-            <a:off x="731520" y="2788920"/>
-            <a:ext cx="914400" cy="182880"/>
-          </a:xfrm>
-          <a:prstGeom prst="rect">
-            <a:avLst>
-              <a:gd name="adj" fmla="val 10000"/>
-            </a:avLst>
-          </a:prstGeom>
-          <a:solidFill>
-            <a:srgbClr val="F5F5F3"/>
-          </a:solidFill>
-          <a:ln/>
-        </p:spPr>
-      </p:sp>
-      <p:sp>
-        <p:nvSpPr>
-          <p:cNvPr id="17" name="Text 15"/>
-          <p:cNvSpPr/>
-          <p:nvPr/>
-        </p:nvSpPr>
-        <p:spPr>
-          <a:xfrm>
-            <a:off x="777240" y="2788920"/>
-            <a:ext cx="822960" cy="182880"/>
-          </a:xfrm>
-          <a:prstGeom prst="rect">
-            <a:avLst/>
-          </a:prstGeom>
-          <a:noFill/>
-          <a:ln/>
-        </p:spPr>
-        <p:txBody>
-          <a:bodyPr wrap="square" rtlCol="0" anchor="ctr"/>
-          <a:lstStyle/>
-          <a:p>
-            <a:pPr algn="ctr" indent="0" marL="0">
-              <a:buNone/>
-            </a:pPr>
-            <a:r>
-              <a:rPr lang="en-US" sz="650" dirty="0">
-                <a:solidFill>
-                  <a:srgbClr val="666666"/>
-                </a:solidFill>
-                <a:latin typeface="JetBrains Mono" pitchFamily="34" charset="0"/>
-                <a:ea typeface="JetBrains Mono" pitchFamily="34" charset="-122"/>
-                <a:cs typeface="JetBrains Mono" pitchFamily="34" charset="-120"/>
-              </a:rPr>
-              <a:t>U.S. TARIFF</a:t>
-            </a:r>
-            <a:endParaRPr lang="en-US" sz="650" dirty="0"/>
-          </a:p>
-        </p:txBody>
-      </p:sp>
-      <p:sp>
-        <p:nvSpPr>
-          <p:cNvPr id="18" name="Text 16"/>
-          <p:cNvSpPr/>
-          <p:nvPr/>
-        </p:nvSpPr>
-        <p:spPr>
-          <a:xfrm>
-            <a:off x="731520" y="3044952"/>
+          <p:cNvPr id="14" name="Text 12"/>
+          <p:cNvSpPr/>
+          <p:nvPr/>
+        </p:nvSpPr>
+        <p:spPr>
+          <a:xfrm>
+            <a:off x="731520" y="2441448"/>
             <a:ext cx="10725912" cy="228600"/>
           </a:xfrm>
           <a:prstGeom prst="rect">
@@ -2849,7 +2816,7 @@
               <a:buNone/>
             </a:pPr>
             <a:r>
-              <a:rPr lang="en-US" sz="1300" b="1" dirty="0">
+              <a:rPr lang="en-US" sz="1200" b="1" dirty="0">
                 <a:solidFill>
                   <a:srgbClr val="1A1A1A"/>
                 </a:solidFill>
@@ -2857,22 +2824,22 @@
                 <a:ea typeface="HarmonyOS Sans SC" pitchFamily="34" charset="-122"/>
                 <a:cs typeface="HarmonyOS Sans SC" pitchFamily="34" charset="-120"/>
               </a:rPr>
-              <a:t>Section 232 半导体关税生效</a:t>
-            </a:r>
-            <a:endParaRPr lang="en-US" sz="1300" dirty="0"/>
-          </a:p>
-        </p:txBody>
-      </p:sp>
-      <p:sp>
-        <p:nvSpPr>
-          <p:cNvPr id="19" name="Text 17"/>
-          <p:cNvSpPr/>
-          <p:nvPr/>
-        </p:nvSpPr>
-        <p:spPr>
-          <a:xfrm>
-            <a:off x="731520" y="3291840"/>
-            <a:ext cx="10725912" cy="548640"/>
+              <a:t>NVIDIA Vera Rubin：从芯片到机架的"极致协同设计"语言</a:t>
+            </a:r>
+            <a:endParaRPr lang="en-US" sz="1200" dirty="0"/>
+          </a:p>
+        </p:txBody>
+      </p:sp>
+      <p:sp>
+        <p:nvSpPr>
+          <p:cNvPr id="15" name="Text 13"/>
+          <p:cNvSpPr/>
+          <p:nvPr/>
+        </p:nvSpPr>
+        <p:spPr>
+          <a:xfrm>
+            <a:off x="731520" y="2697480"/>
+            <a:ext cx="10725912" cy="502920"/>
           </a:xfrm>
           <a:prstGeom prst="rect">
             <a:avLst/>
@@ -2899,7 +2866,7 @@
                 <a:ea typeface="HarmonyOS Sans SC" pitchFamily="34" charset="-122"/>
                 <a:cs typeface="HarmonyOS Sans SC" pitchFamily="34" charset="-120"/>
               </a:rPr>
-              <a:t>1 月 15 日起对特定先进芯片征收 25% 关税（涵盖 Nvidia H200、AMD MI325X 等），但豁免数据中心、研发等场景。7 月 1 日将评估是否扩大范围。</a:t>
+              <a:t>NVIDIA 在 CES 和 GTC 2026 发布 Vera Rubin 平台——6 颗芯片（Vera CPU、Rubin GPU、NVLink 6、ConnectX-9、BlueField-4、Spectrum-6）协同设计为一个统一的 AI 超级计算机机架，不再是独立芯片的简单组合。这标志着 AI 硬件发布的新视觉语言：整机架即产品。</a:t>
             </a:r>
             <a:endParaRPr lang="en-US" sz="1000" dirty="0"/>
           </a:p>
@@ -2907,13 +2874,13 @@
       </p:sp>
       <p:sp>
         <p:nvSpPr>
-          <p:cNvPr id="20" name="Shape 18"/>
-          <p:cNvSpPr/>
-          <p:nvPr/>
-        </p:nvSpPr>
-        <p:spPr>
-          <a:xfrm>
-            <a:off x="731520" y="4023360"/>
+          <p:cNvPr id="16" name="Shape 14"/>
+          <p:cNvSpPr/>
+          <p:nvPr/>
+        </p:nvSpPr>
+        <p:spPr>
+          <a:xfrm>
+            <a:off x="731520" y="3355848"/>
             <a:ext cx="10725912" cy="0"/>
           </a:xfrm>
           <a:prstGeom prst="line">
@@ -2930,74 +2897,13 @@
       </p:sp>
       <p:sp>
         <p:nvSpPr>
-          <p:cNvPr id="21" name="Shape 19"/>
-          <p:cNvSpPr/>
-          <p:nvPr/>
-        </p:nvSpPr>
-        <p:spPr>
-          <a:xfrm>
-            <a:off x="731520" y="4160520"/>
-            <a:ext cx="914400" cy="182880"/>
-          </a:xfrm>
-          <a:prstGeom prst="rect">
-            <a:avLst>
-              <a:gd name="adj" fmla="val 10000"/>
-            </a:avLst>
-          </a:prstGeom>
-          <a:solidFill>
-            <a:srgbClr val="F5F5F3"/>
-          </a:solidFill>
-          <a:ln/>
-        </p:spPr>
-      </p:sp>
-      <p:sp>
-        <p:nvSpPr>
-          <p:cNvPr id="22" name="Text 20"/>
-          <p:cNvSpPr/>
-          <p:nvPr/>
-        </p:nvSpPr>
-        <p:spPr>
-          <a:xfrm>
-            <a:off x="777240" y="4160520"/>
-            <a:ext cx="822960" cy="182880"/>
-          </a:xfrm>
-          <a:prstGeom prst="rect">
-            <a:avLst/>
-          </a:prstGeom>
-          <a:noFill/>
-          <a:ln/>
-        </p:spPr>
-        <p:txBody>
-          <a:bodyPr wrap="square" rtlCol="0" anchor="ctr"/>
-          <a:lstStyle/>
-          <a:p>
-            <a:pPr algn="ctr" indent="0" marL="0">
-              <a:buNone/>
-            </a:pPr>
-            <a:r>
-              <a:rPr lang="en-US" sz="650" dirty="0">
-                <a:solidFill>
-                  <a:srgbClr val="666666"/>
-                </a:solidFill>
-                <a:latin typeface="JetBrains Mono" pitchFamily="34" charset="0"/>
-                <a:ea typeface="JetBrains Mono" pitchFamily="34" charset="-122"/>
-                <a:cs typeface="JetBrains Mono" pitchFamily="34" charset="-120"/>
-              </a:rPr>
-              <a:t>CHIPS ACT</a:t>
-            </a:r>
-            <a:endParaRPr lang="en-US" sz="650" dirty="0"/>
-          </a:p>
-        </p:txBody>
-      </p:sp>
-      <p:sp>
-        <p:nvSpPr>
-          <p:cNvPr id="23" name="Text 21"/>
-          <p:cNvSpPr/>
-          <p:nvPr/>
-        </p:nvSpPr>
-        <p:spPr>
-          <a:xfrm>
-            <a:off x="731520" y="4416552"/>
+          <p:cNvPr id="17" name="Text 15"/>
+          <p:cNvSpPr/>
+          <p:nvPr/>
+        </p:nvSpPr>
+        <p:spPr>
+          <a:xfrm>
+            <a:off x="731520" y="3465576"/>
             <a:ext cx="10725912" cy="228600"/>
           </a:xfrm>
           <a:prstGeom prst="rect">
@@ -3014,7 +2920,7 @@
               <a:buNone/>
             </a:pPr>
             <a:r>
-              <a:rPr lang="en-US" sz="1300" b="1" dirty="0">
+              <a:rPr lang="en-US" sz="1200" b="1" dirty="0">
                 <a:solidFill>
                   <a:srgbClr val="1A1A1A"/>
                 </a:solidFill>
@@ -3022,22 +2928,22 @@
                 <a:ea typeface="HarmonyOS Sans SC" pitchFamily="34" charset="-122"/>
                 <a:cs typeface="HarmonyOS Sans SC" pitchFamily="34" charset="-120"/>
               </a:rPr>
-              <a:t>CHIPS Act 税收优惠面临到期</a:t>
-            </a:r>
-            <a:endParaRPr lang="en-US" sz="1300" dirty="0"/>
-          </a:p>
-        </p:txBody>
-      </p:sp>
-      <p:sp>
-        <p:nvSpPr>
-          <p:cNvPr id="24" name="Text 22"/>
-          <p:cNvSpPr/>
-          <p:nvPr/>
-        </p:nvSpPr>
-        <p:spPr>
-          <a:xfrm>
-            <a:off x="731520" y="4663440"/>
-            <a:ext cx="10725912" cy="548640"/>
+              <a:t>Siemens Digital Twin Composer：HMI 从仪表盘走向可导航虚拟孪生</a:t>
+            </a:r>
+            <a:endParaRPr lang="en-US" sz="1200" dirty="0"/>
+          </a:p>
+        </p:txBody>
+      </p:sp>
+      <p:sp>
+        <p:nvSpPr>
+          <p:cNvPr id="18" name="Text 16"/>
+          <p:cNvSpPr/>
+          <p:nvPr/>
+        </p:nvSpPr>
+        <p:spPr>
+          <a:xfrm>
+            <a:off x="731520" y="3721608"/>
+            <a:ext cx="10725912" cy="502920"/>
           </a:xfrm>
           <a:prstGeom prst="rect">
             <a:avLst/>
@@ -3064,7 +2970,7 @@
                 <a:ea typeface="HarmonyOS Sans SC" pitchFamily="34" charset="-122"/>
                 <a:cs typeface="HarmonyOS Sans SC" pitchFamily="34" charset="-120"/>
               </a:rPr>
-              <a:t>TSMC 宣布追加 $1,000 亿美国投资。但 Section 48D 先进制造投资税收抵免将于 2026 年到期，续期前景不明。</a:t>
+              <a:t>Siemens 在 CES 2026 发布 Digital Twin Composer，基于 NVIDIA Omniverse 将 2D/3D 数字孪生数据与实时遥测统一到一个场景中。"一个模型贯穿设计、仿真、运行"的理念，把晶圆厂操作员 HMI 从平面仪表盘重塑为可导航的虚拟孪生空间。2026 年中上线 Siemens Xcelerator 市场。</a:t>
             </a:r>
             <a:endParaRPr lang="en-US" sz="1000" dirty="0"/>
           </a:p>
@@ -3072,13 +2978,13 @@
       </p:sp>
       <p:sp>
         <p:nvSpPr>
-          <p:cNvPr id="25" name="Shape 23"/>
-          <p:cNvSpPr/>
-          <p:nvPr/>
-        </p:nvSpPr>
-        <p:spPr>
-          <a:xfrm>
-            <a:off x="731520" y="5394960"/>
+          <p:cNvPr id="19" name="Shape 17"/>
+          <p:cNvSpPr/>
+          <p:nvPr/>
+        </p:nvSpPr>
+        <p:spPr>
+          <a:xfrm>
+            <a:off x="731520" y="4379976"/>
             <a:ext cx="10725912" cy="0"/>
           </a:xfrm>
           <a:prstGeom prst="line">
@@ -3095,124 +3001,107 @@
       </p:sp>
       <p:sp>
         <p:nvSpPr>
-          <p:cNvPr id="26" name="Shape 24"/>
-          <p:cNvSpPr/>
-          <p:nvPr/>
-        </p:nvSpPr>
-        <p:spPr>
-          <a:xfrm>
-            <a:off x="731520" y="5532120"/>
-            <a:ext cx="10725912" cy="731520"/>
-          </a:xfrm>
-          <a:prstGeom prst="rect">
-            <a:avLst/>
-          </a:prstGeom>
-          <a:solidFill>
-            <a:srgbClr val="F5F5F3"/>
-          </a:solidFill>
-          <a:ln/>
-        </p:spPr>
-      </p:sp>
-      <p:sp>
-        <p:nvSpPr>
-          <p:cNvPr id="27" name="Shape 25"/>
-          <p:cNvSpPr/>
-          <p:nvPr/>
-        </p:nvSpPr>
-        <p:spPr>
-          <a:xfrm>
-            <a:off x="731520" y="5532120"/>
-            <a:ext cx="36576" cy="731520"/>
-          </a:xfrm>
-          <a:prstGeom prst="rect">
-            <a:avLst/>
-          </a:prstGeom>
-          <a:solidFill>
-            <a:srgbClr val="141414"/>
-          </a:solidFill>
-          <a:ln/>
-        </p:spPr>
-      </p:sp>
-      <p:sp>
-        <p:nvSpPr>
-          <p:cNvPr id="28" name="Text 26"/>
-          <p:cNvSpPr/>
-          <p:nvPr/>
-        </p:nvSpPr>
-        <p:spPr>
-          <a:xfrm>
-            <a:off x="868680" y="5577840"/>
-            <a:ext cx="2743200" cy="137160"/>
-          </a:xfrm>
-          <a:prstGeom prst="rect">
-            <a:avLst/>
-          </a:prstGeom>
-          <a:noFill/>
-          <a:ln/>
-        </p:spPr>
-        <p:txBody>
-          <a:bodyPr wrap="square" rtlCol="0" anchor="ctr"/>
-          <a:lstStyle/>
-          <a:p>
-            <a:pPr indent="0" marL="0">
-              <a:buNone/>
-            </a:pPr>
-            <a:r>
-              <a:rPr lang="en-US" sz="650" dirty="0">
-                <a:solidFill>
-                  <a:srgbClr val="999999"/>
-                </a:solidFill>
-                <a:latin typeface="JetBrains Mono" pitchFamily="34" charset="0"/>
-                <a:ea typeface="JetBrains Mono" pitchFamily="34" charset="-122"/>
-                <a:cs typeface="JetBrains Mono" pitchFamily="34" charset="-120"/>
-              </a:rPr>
-              <a:t>FAB EXPANSION</a:t>
-            </a:r>
-            <a:endParaRPr lang="en-US" sz="650" dirty="0"/>
-          </a:p>
-        </p:txBody>
-      </p:sp>
-      <p:sp>
-        <p:nvSpPr>
-          <p:cNvPr id="29" name="Text 27"/>
-          <p:cNvSpPr/>
-          <p:nvPr/>
-        </p:nvSpPr>
-        <p:spPr>
-          <a:xfrm>
-            <a:off x="868680" y="5715000"/>
-            <a:ext cx="10451592" cy="502920"/>
-          </a:xfrm>
-          <a:prstGeom prst="rect">
-            <a:avLst/>
-          </a:prstGeom>
-          <a:noFill/>
-          <a:ln/>
-        </p:spPr>
-        <p:txBody>
-          <a:bodyPr wrap="square" rtlCol="0" anchor="ctr"/>
-          <a:lstStyle/>
-          <a:p>
-            <a:pPr indent="0" marL="0">
-              <a:lnSpc>
-                <a:spcPct val="150000"/>
-              </a:lnSpc>
-              <a:buNone/>
-            </a:pPr>
-            <a:r>
-              <a:rPr lang="en-US" sz="950" dirty="0">
-                <a:solidFill>
-                  <a:srgbClr val="333333"/>
+          <p:cNvPr id="20" name="Text 18"/>
+          <p:cNvSpPr/>
+          <p:nvPr/>
+        </p:nvSpPr>
+        <p:spPr>
+          <a:xfrm>
+            <a:off x="731520" y="4489704"/>
+            <a:ext cx="10725912" cy="228600"/>
+          </a:xfrm>
+          <a:prstGeom prst="rect">
+            <a:avLst/>
+          </a:prstGeom>
+          <a:noFill/>
+          <a:ln/>
+        </p:spPr>
+        <p:txBody>
+          <a:bodyPr wrap="square" rtlCol="0" anchor="ctr"/>
+          <a:lstStyle/>
+          <a:p>
+            <a:pPr indent="0" marL="0">
+              <a:buNone/>
+            </a:pPr>
+            <a:r>
+              <a:rPr lang="en-US" sz="1200" b="1" dirty="0">
+                <a:solidFill>
+                  <a:srgbClr val="1A1A1A"/>
                 </a:solidFill>
                 <a:latin typeface="HarmonyOS Sans SC" pitchFamily="34" charset="0"/>
                 <a:ea typeface="HarmonyOS Sans SC" pitchFamily="34" charset="-122"/>
                 <a:cs typeface="HarmonyOS Sans SC" pitchFamily="34" charset="-120"/>
               </a:rPr>
-              <a:t>TSMC 亚利桑那规模扩大至最多 12 座晶圆厂 + 4 座先进封装厂；台湾同步推进 10 座新厂。全球 2025 年新开工 18 个晶圆厂项目（3 座 200mm + 15 座 300mm），美洲和日本各 4 个领跑。</a:t>
-            </a:r>
-            <a:endParaRPr lang="en-US" sz="950" dirty="0"/>
-          </a:p>
-        </p:txBody>
+              <a:t>Intel 18A 首秀：Core Ultra Series 3 的工业设计宣言</a:t>
+            </a:r>
+            <a:endParaRPr lang="en-US" sz="1200" dirty="0"/>
+          </a:p>
+        </p:txBody>
+      </p:sp>
+      <p:sp>
+        <p:nvSpPr>
+          <p:cNvPr id="21" name="Text 19"/>
+          <p:cNvSpPr/>
+          <p:nvPr/>
+        </p:nvSpPr>
+        <p:spPr>
+          <a:xfrm>
+            <a:off x="731520" y="4745736"/>
+            <a:ext cx="10725912" cy="502920"/>
+          </a:xfrm>
+          <a:prstGeom prst="rect">
+            <a:avLst/>
+          </a:prstGeom>
+          <a:noFill/>
+          <a:ln/>
+        </p:spPr>
+        <p:txBody>
+          <a:bodyPr wrap="square" rtlCol="0" anchor="ctr"/>
+          <a:lstStyle/>
+          <a:p>
+            <a:pPr indent="0" marL="0">
+              <a:lnSpc>
+                <a:spcPct val="160000"/>
+              </a:lnSpc>
+              <a:buNone/>
+            </a:pPr>
+            <a:r>
+              <a:rPr lang="en-US" sz="1000" dirty="0">
+                <a:solidFill>
+                  <a:srgbClr val="333333"/>
+                </a:solidFill>
+                <a:latin typeface="HarmonyOS Sans SC" pitchFamily="34" charset="0"/>
+                <a:ea typeface="HarmonyOS Sans SC" pitchFamily="34" charset="-122"/>
+                <a:cs typeface="HarmonyOS Sans SC" pitchFamily="34" charset="-120"/>
+              </a:rPr>
+              <a:t>Intel 在 CES 2026 发布首款 Intel 18A 量产消费平台 Core Ultra Series 3，把"美国制造"作为工业设计语言的核心叙事，将芯片封装与品牌视觉绑定到 CEO 林本坚领导下的 Intel Foundry 复兴故事。</a:t>
+            </a:r>
+            <a:endParaRPr lang="en-US" sz="1000" dirty="0"/>
+          </a:p>
+        </p:txBody>
+      </p:sp>
+      <p:sp>
+        <p:nvSpPr>
+          <p:cNvPr id="22" name="Shape 20"/>
+          <p:cNvSpPr/>
+          <p:nvPr/>
+        </p:nvSpPr>
+        <p:spPr>
+          <a:xfrm>
+            <a:off x="731520" y="5404104"/>
+            <a:ext cx="10725912" cy="0"/>
+          </a:xfrm>
+          <a:prstGeom prst="line">
+            <a:avLst/>
+          </a:prstGeom>
+          <a:noFill/>
+          <a:ln w="3810">
+            <a:solidFill>
+              <a:srgbClr val="E0E0E0"/>
+            </a:solidFill>
+            <a:prstDash val="solid"/>
+          </a:ln>
+        </p:spPr>
       </p:sp>
     </p:spTree>
   </p:cSld>
@@ -3435,7 +3324,7 @@
                 <a:ea typeface="JetBrains Mono" pitchFamily="34" charset="-122"/>
                 <a:cs typeface="JetBrains Mono" pitchFamily="34" charset="-120"/>
               </a:rPr>
-              <a:t>11 / 12</a:t>
+              <a:t>11 / 13</a:t>
             </a:r>
             <a:endParaRPr lang="en-US" sz="650" dirty="0"/>
           </a:p>
@@ -3474,7 +3363,7 @@
                 <a:ea typeface="JetBrains Mono" pitchFamily="34" charset="-122"/>
                 <a:cs typeface="JetBrains Mono" pitchFamily="34" charset="-120"/>
               </a:rPr>
-              <a:t>10</a:t>
+              <a:t>09</a:t>
             </a:r>
             <a:endParaRPr lang="en-US" sz="700" dirty="0"/>
           </a:p>
@@ -3513,7 +3402,7 @@
                 <a:ea typeface="HarmonyOS Sans SC" pitchFamily="34" charset="-122"/>
                 <a:cs typeface="HarmonyOS Sans SC" pitchFamily="34" charset="-120"/>
               </a:rPr>
-              <a:t>值得一读</a:t>
+              <a:t>政策与地缘</a:t>
             </a:r>
             <a:endParaRPr lang="en-US" sz="2200" dirty="0"/>
           </a:p>
@@ -3552,7 +3441,7 @@
                 <a:ea typeface="JetBrains Mono" pitchFamily="34" charset="-122"/>
                 <a:cs typeface="JetBrains Mono" pitchFamily="34" charset="-120"/>
               </a:rPr>
-              <a:t>WORTH READING</a:t>
+              <a:t>POLICY &amp; GEOPOLITICS</a:t>
             </a:r>
             <a:endParaRPr lang="en-US" sz="700" dirty="0"/>
           </a:p>
@@ -3560,69 +3449,91 @@
       </p:sp>
       <p:sp>
         <p:nvSpPr>
-          <p:cNvPr id="11" name="Text 9"/>
+          <p:cNvPr id="11" name="Shape 9"/>
           <p:cNvSpPr/>
           <p:nvPr/>
         </p:nvSpPr>
         <p:spPr>
           <a:xfrm>
             <a:off x="731520" y="1417320"/>
-            <a:ext cx="365760" cy="274320"/>
-          </a:xfrm>
-          <a:prstGeom prst="rect">
-            <a:avLst/>
-          </a:prstGeom>
-          <a:noFill/>
-          <a:ln/>
-        </p:spPr>
-        <p:txBody>
-          <a:bodyPr wrap="square" rtlCol="0" anchor="ctr"/>
-          <a:lstStyle/>
-          <a:p>
-            <a:pPr indent="0" marL="0">
-              <a:buNone/>
-            </a:pPr>
-            <a:r>
-              <a:rPr lang="en-US" sz="1800" dirty="0">
-                <a:solidFill>
-                  <a:srgbClr val="E0E0E0"/>
+            <a:ext cx="914400" cy="182880"/>
+          </a:xfrm>
+          <a:prstGeom prst="rect">
+            <a:avLst>
+              <a:gd name="adj" fmla="val 10000"/>
+            </a:avLst>
+          </a:prstGeom>
+          <a:solidFill>
+            <a:srgbClr val="F5F5F3"/>
+          </a:solidFill>
+          <a:ln/>
+        </p:spPr>
+      </p:sp>
+      <p:sp>
+        <p:nvSpPr>
+          <p:cNvPr id="12" name="Text 10"/>
+          <p:cNvSpPr/>
+          <p:nvPr/>
+        </p:nvSpPr>
+        <p:spPr>
+          <a:xfrm>
+            <a:off x="777240" y="1417320"/>
+            <a:ext cx="822960" cy="182880"/>
+          </a:xfrm>
+          <a:prstGeom prst="rect">
+            <a:avLst/>
+          </a:prstGeom>
+          <a:noFill/>
+          <a:ln/>
+        </p:spPr>
+        <p:txBody>
+          <a:bodyPr wrap="square" rtlCol="0" anchor="ctr"/>
+          <a:lstStyle/>
+          <a:p>
+            <a:pPr algn="ctr" indent="0" marL="0">
+              <a:buNone/>
+            </a:pPr>
+            <a:r>
+              <a:rPr lang="en-US" sz="650" dirty="0">
+                <a:solidFill>
+                  <a:srgbClr val="666666"/>
                 </a:solidFill>
                 <a:latin typeface="JetBrains Mono" pitchFamily="34" charset="0"/>
                 <a:ea typeface="JetBrains Mono" pitchFamily="34" charset="-122"/>
                 <a:cs typeface="JetBrains Mono" pitchFamily="34" charset="-120"/>
               </a:rPr>
-              <a:t>01</a:t>
-            </a:r>
-            <a:endParaRPr lang="en-US" sz="1800" dirty="0"/>
-          </a:p>
-        </p:txBody>
-      </p:sp>
-      <p:sp>
-        <p:nvSpPr>
-          <p:cNvPr id="12" name="Text 10"/>
-          <p:cNvSpPr/>
-          <p:nvPr/>
-        </p:nvSpPr>
-        <p:spPr>
-          <a:xfrm>
-            <a:off x="1188720" y="1417320"/>
-            <a:ext cx="10268712" cy="228600"/>
-          </a:xfrm>
-          <a:prstGeom prst="rect">
-            <a:avLst/>
-          </a:prstGeom>
-          <a:noFill/>
-          <a:ln/>
-        </p:spPr>
-        <p:txBody>
-          <a:bodyPr wrap="square" rtlCol="0" anchor="ctr"/>
-          <a:lstStyle/>
-          <a:p>
-            <a:pPr indent="0" marL="0">
-              <a:buNone/>
-            </a:pPr>
-            <a:r>
-              <a:rPr lang="en-US" sz="1100" b="1" dirty="0">
+              <a:t>U.S. CONGRESS</a:t>
+            </a:r>
+            <a:endParaRPr lang="en-US" sz="650" dirty="0"/>
+          </a:p>
+        </p:txBody>
+      </p:sp>
+      <p:sp>
+        <p:nvSpPr>
+          <p:cNvPr id="13" name="Text 11"/>
+          <p:cNvSpPr/>
+          <p:nvPr/>
+        </p:nvSpPr>
+        <p:spPr>
+          <a:xfrm>
+            <a:off x="731520" y="1673352"/>
+            <a:ext cx="10725912" cy="228600"/>
+          </a:xfrm>
+          <a:prstGeom prst="rect">
+            <a:avLst/>
+          </a:prstGeom>
+          <a:noFill/>
+          <a:ln/>
+        </p:spPr>
+        <p:txBody>
+          <a:bodyPr wrap="square" rtlCol="0" anchor="ctr"/>
+          <a:lstStyle/>
+          <a:p>
+            <a:pPr indent="0" marL="0">
+              <a:buNone/>
+            </a:pPr>
+            <a:r>
+              <a:rPr lang="en-US" sz="1300" b="1" dirty="0">
                 <a:solidFill>
                   <a:srgbClr val="1A1A1A"/>
                 </a:solidFill>
@@ -3630,48 +3541,9 @@
                 <a:ea typeface="HarmonyOS Sans SC" pitchFamily="34" charset="-122"/>
                 <a:cs typeface="HarmonyOS Sans SC" pitchFamily="34" charset="-120"/>
               </a:rPr>
-              <a:t>SEMI: Global 300mm Fab Equipment Spending to Reach $151B by 2027</a:t>
-            </a:r>
-            <a:endParaRPr lang="en-US" sz="1100" dirty="0"/>
-          </a:p>
-        </p:txBody>
-      </p:sp>
-      <p:sp>
-        <p:nvSpPr>
-          <p:cNvPr id="13" name="Text 11"/>
-          <p:cNvSpPr/>
-          <p:nvPr/>
-        </p:nvSpPr>
-        <p:spPr>
-          <a:xfrm>
-            <a:off x="1188720" y="1645920"/>
-            <a:ext cx="2743200" cy="137160"/>
-          </a:xfrm>
-          <a:prstGeom prst="rect">
-            <a:avLst/>
-          </a:prstGeom>
-          <a:noFill/>
-          <a:ln/>
-        </p:spPr>
-        <p:txBody>
-          <a:bodyPr wrap="square" rtlCol="0" anchor="ctr"/>
-          <a:lstStyle/>
-          <a:p>
-            <a:pPr indent="0" marL="0">
-              <a:buNone/>
-            </a:pPr>
-            <a:r>
-              <a:rPr lang="en-US" sz="700" dirty="0">
-                <a:solidFill>
-                  <a:srgbClr val="999999"/>
-                </a:solidFill>
-                <a:latin typeface="JetBrains Mono" pitchFamily="34" charset="0"/>
-                <a:ea typeface="JetBrains Mono" pitchFamily="34" charset="-122"/>
-                <a:cs typeface="JetBrains Mono" pitchFamily="34" charset="-120"/>
-              </a:rPr>
-              <a:t>SEMI.org · Apr 8, 2026</a:t>
-            </a:r>
-            <a:endParaRPr lang="en-US" sz="700" dirty="0"/>
+              <a:t>MATCH Act：封堵 DUV 对华出口</a:t>
+            </a:r>
+            <a:endParaRPr lang="en-US" sz="1300" dirty="0"/>
           </a:p>
         </p:txBody>
       </p:sp>
@@ -3683,8 +3555,8 @@
         </p:nvSpPr>
         <p:spPr>
           <a:xfrm>
-            <a:off x="1188720" y="1801368"/>
-            <a:ext cx="10268712" cy="274320"/>
+            <a:off x="731520" y="1920240"/>
+            <a:ext cx="10725912" cy="548640"/>
           </a:xfrm>
           <a:prstGeom prst="rect">
             <a:avLst/>
@@ -3698,22 +3570,22 @@
           <a:p>
             <a:pPr indent="0" marL="0">
               <a:lnSpc>
-                <a:spcPct val="140000"/>
+                <a:spcPct val="160000"/>
               </a:lnSpc>
               <a:buNone/>
             </a:pPr>
             <a:r>
-              <a:rPr lang="en-US" sz="900" dirty="0">
-                <a:solidFill>
-                  <a:srgbClr val="666666"/>
+              <a:rPr lang="en-US" sz="1000" dirty="0">
+                <a:solidFill>
+                  <a:srgbClr val="333333"/>
                 </a:solidFill>
                 <a:latin typeface="HarmonyOS Sans SC" pitchFamily="34" charset="0"/>
                 <a:ea typeface="HarmonyOS Sans SC" pitchFamily="34" charset="-122"/>
                 <a:cs typeface="HarmonyOS Sans SC" pitchFamily="34" charset="-120"/>
               </a:rPr>
-              <a:t>SEMI 最新预测报告，详细拆解各地区、各环节设备投资趋势。</a:t>
-            </a:r>
-            <a:endParaRPr lang="en-US" sz="900" dirty="0"/>
+              <a:t>4 月 2 日众议院推出 MATCH Act，目标收紧 ASML DUV 光刻机对华出口，施压荷兰、日本盟友全面对齐美国管制标准。JPMorgan 估计若实施，ASML EPS 可能下降 10%。</a:t>
+            </a:r>
+            <a:endParaRPr lang="en-US" sz="1000" dirty="0"/>
           </a:p>
         </p:txBody>
       </p:sp>
@@ -3725,7 +3597,7 @@
         </p:nvSpPr>
         <p:spPr>
           <a:xfrm>
-            <a:off x="731520" y="2240280"/>
+            <a:off x="731520" y="2651760"/>
             <a:ext cx="10725912" cy="0"/>
           </a:xfrm>
           <a:prstGeom prst="line">
@@ -3742,69 +3614,91 @@
       </p:sp>
       <p:sp>
         <p:nvSpPr>
-          <p:cNvPr id="16" name="Text 14"/>
-          <p:cNvSpPr/>
-          <p:nvPr/>
-        </p:nvSpPr>
-        <p:spPr>
-          <a:xfrm>
-            <a:off x="731520" y="2331720"/>
-            <a:ext cx="365760" cy="274320"/>
-          </a:xfrm>
-          <a:prstGeom prst="rect">
-            <a:avLst/>
-          </a:prstGeom>
-          <a:noFill/>
-          <a:ln/>
-        </p:spPr>
-        <p:txBody>
-          <a:bodyPr wrap="square" rtlCol="0" anchor="ctr"/>
-          <a:lstStyle/>
-          <a:p>
-            <a:pPr indent="0" marL="0">
-              <a:buNone/>
-            </a:pPr>
-            <a:r>
-              <a:rPr lang="en-US" sz="1800" dirty="0">
-                <a:solidFill>
-                  <a:srgbClr val="E0E0E0"/>
+          <p:cNvPr id="16" name="Shape 14"/>
+          <p:cNvSpPr/>
+          <p:nvPr/>
+        </p:nvSpPr>
+        <p:spPr>
+          <a:xfrm>
+            <a:off x="731520" y="2788920"/>
+            <a:ext cx="914400" cy="182880"/>
+          </a:xfrm>
+          <a:prstGeom prst="rect">
+            <a:avLst>
+              <a:gd name="adj" fmla="val 10000"/>
+            </a:avLst>
+          </a:prstGeom>
+          <a:solidFill>
+            <a:srgbClr val="F5F5F3"/>
+          </a:solidFill>
+          <a:ln/>
+        </p:spPr>
+      </p:sp>
+      <p:sp>
+        <p:nvSpPr>
+          <p:cNvPr id="17" name="Text 15"/>
+          <p:cNvSpPr/>
+          <p:nvPr/>
+        </p:nvSpPr>
+        <p:spPr>
+          <a:xfrm>
+            <a:off x="777240" y="2788920"/>
+            <a:ext cx="822960" cy="182880"/>
+          </a:xfrm>
+          <a:prstGeom prst="rect">
+            <a:avLst/>
+          </a:prstGeom>
+          <a:noFill/>
+          <a:ln/>
+        </p:spPr>
+        <p:txBody>
+          <a:bodyPr wrap="square" rtlCol="0" anchor="ctr"/>
+          <a:lstStyle/>
+          <a:p>
+            <a:pPr algn="ctr" indent="0" marL="0">
+              <a:buNone/>
+            </a:pPr>
+            <a:r>
+              <a:rPr lang="en-US" sz="650" dirty="0">
+                <a:solidFill>
+                  <a:srgbClr val="666666"/>
                 </a:solidFill>
                 <a:latin typeface="JetBrains Mono" pitchFamily="34" charset="0"/>
                 <a:ea typeface="JetBrains Mono" pitchFamily="34" charset="-122"/>
                 <a:cs typeface="JetBrains Mono" pitchFamily="34" charset="-120"/>
               </a:rPr>
-              <a:t>02</a:t>
-            </a:r>
-            <a:endParaRPr lang="en-US" sz="1800" dirty="0"/>
-          </a:p>
-        </p:txBody>
-      </p:sp>
-      <p:sp>
-        <p:nvSpPr>
-          <p:cNvPr id="17" name="Text 15"/>
-          <p:cNvSpPr/>
-          <p:nvPr/>
-        </p:nvSpPr>
-        <p:spPr>
-          <a:xfrm>
-            <a:off x="1188720" y="2331720"/>
-            <a:ext cx="10268712" cy="228600"/>
-          </a:xfrm>
-          <a:prstGeom prst="rect">
-            <a:avLst/>
-          </a:prstGeom>
-          <a:noFill/>
-          <a:ln/>
-        </p:spPr>
-        <p:txBody>
-          <a:bodyPr wrap="square" rtlCol="0" anchor="ctr"/>
-          <a:lstStyle/>
-          <a:p>
-            <a:pPr indent="0" marL="0">
-              <a:buNone/>
-            </a:pPr>
-            <a:r>
-              <a:rPr lang="en-US" sz="1100" b="1" dirty="0">
+              <a:t>U.S. TARIFF</a:t>
+            </a:r>
+            <a:endParaRPr lang="en-US" sz="650" dirty="0"/>
+          </a:p>
+        </p:txBody>
+      </p:sp>
+      <p:sp>
+        <p:nvSpPr>
+          <p:cNvPr id="18" name="Text 16"/>
+          <p:cNvSpPr/>
+          <p:nvPr/>
+        </p:nvSpPr>
+        <p:spPr>
+          <a:xfrm>
+            <a:off x="731520" y="3044952"/>
+            <a:ext cx="10725912" cy="228600"/>
+          </a:xfrm>
+          <a:prstGeom prst="rect">
+            <a:avLst/>
+          </a:prstGeom>
+          <a:noFill/>
+          <a:ln/>
+        </p:spPr>
+        <p:txBody>
+          <a:bodyPr wrap="square" rtlCol="0" anchor="ctr"/>
+          <a:lstStyle/>
+          <a:p>
+            <a:pPr indent="0" marL="0">
+              <a:buNone/>
+            </a:pPr>
+            <a:r>
+              <a:rPr lang="en-US" sz="1300" b="1" dirty="0">
                 <a:solidFill>
                   <a:srgbClr val="1A1A1A"/>
                 </a:solidFill>
@@ -3812,48 +3706,9 @@
                 <a:ea typeface="HarmonyOS Sans SC" pitchFamily="34" charset="-122"/>
                 <a:cs typeface="HarmonyOS Sans SC" pitchFamily="34" charset="-120"/>
               </a:rPr>
-              <a:t>Backside Power Delivery Nears Production</a:t>
-            </a:r>
-            <a:endParaRPr lang="en-US" sz="1100" dirty="0"/>
-          </a:p>
-        </p:txBody>
-      </p:sp>
-      <p:sp>
-        <p:nvSpPr>
-          <p:cNvPr id="18" name="Text 16"/>
-          <p:cNvSpPr/>
-          <p:nvPr/>
-        </p:nvSpPr>
-        <p:spPr>
-          <a:xfrm>
-            <a:off x="1188720" y="2560320"/>
-            <a:ext cx="2743200" cy="137160"/>
-          </a:xfrm>
-          <a:prstGeom prst="rect">
-            <a:avLst/>
-          </a:prstGeom>
-          <a:noFill/>
-          <a:ln/>
-        </p:spPr>
-        <p:txBody>
-          <a:bodyPr wrap="square" rtlCol="0" anchor="ctr"/>
-          <a:lstStyle/>
-          <a:p>
-            <a:pPr indent="0" marL="0">
-              <a:buNone/>
-            </a:pPr>
-            <a:r>
-              <a:rPr lang="en-US" sz="700" dirty="0">
-                <a:solidFill>
-                  <a:srgbClr val="999999"/>
-                </a:solidFill>
-                <a:latin typeface="JetBrains Mono" pitchFamily="34" charset="0"/>
-                <a:ea typeface="JetBrains Mono" pitchFamily="34" charset="-122"/>
-                <a:cs typeface="JetBrains Mono" pitchFamily="34" charset="-120"/>
-              </a:rPr>
-              <a:t>SemiEngineering · Mar 2026</a:t>
-            </a:r>
-            <a:endParaRPr lang="en-US" sz="700" dirty="0"/>
+              <a:t>Section 232 半导体关税生效</a:t>
+            </a:r>
+            <a:endParaRPr lang="en-US" sz="1300" dirty="0"/>
           </a:p>
         </p:txBody>
       </p:sp>
@@ -3865,8 +3720,8 @@
         </p:nvSpPr>
         <p:spPr>
           <a:xfrm>
-            <a:off x="1188720" y="2715768"/>
-            <a:ext cx="10268712" cy="274320"/>
+            <a:off x="731520" y="3291840"/>
+            <a:ext cx="10725912" cy="548640"/>
           </a:xfrm>
           <a:prstGeom prst="rect">
             <a:avLst/>
@@ -3880,22 +3735,22 @@
           <a:p>
             <a:pPr indent="0" marL="0">
               <a:lnSpc>
-                <a:spcPct val="140000"/>
+                <a:spcPct val="160000"/>
               </a:lnSpc>
               <a:buNone/>
             </a:pPr>
             <a:r>
-              <a:rPr lang="en-US" sz="900" dirty="0">
-                <a:solidFill>
-                  <a:srgbClr val="666666"/>
+              <a:rPr lang="en-US" sz="1000" dirty="0">
+                <a:solidFill>
+                  <a:srgbClr val="333333"/>
                 </a:solidFill>
                 <a:latin typeface="HarmonyOS Sans SC" pitchFamily="34" charset="0"/>
                 <a:ea typeface="HarmonyOS Sans SC" pitchFamily="34" charset="-122"/>
                 <a:cs typeface="HarmonyOS Sans SC" pitchFamily="34" charset="-120"/>
               </a:rPr>
-              <a:t>深度解析背面供电技术的量产挑战，涵盖 TSMC、Intel、Samsung 的不同技术路线。</a:t>
-            </a:r>
-            <a:endParaRPr lang="en-US" sz="900" dirty="0"/>
+              <a:t>1 月 15 日起对特定先进芯片征收 25% 关税（涵盖 Nvidia H200、AMD MI325X 等），但豁免数据中心、研发等场景。7 月 1 日将评估是否扩大范围。</a:t>
+            </a:r>
+            <a:endParaRPr lang="en-US" sz="1000" dirty="0"/>
           </a:p>
         </p:txBody>
       </p:sp>
@@ -3907,7 +3762,7 @@
         </p:nvSpPr>
         <p:spPr>
           <a:xfrm>
-            <a:off x="731520" y="3154680"/>
+            <a:off x="731520" y="4023360"/>
             <a:ext cx="10725912" cy="0"/>
           </a:xfrm>
           <a:prstGeom prst="line">
@@ -3924,69 +3779,91 @@
       </p:sp>
       <p:sp>
         <p:nvSpPr>
-          <p:cNvPr id="21" name="Text 19"/>
-          <p:cNvSpPr/>
-          <p:nvPr/>
-        </p:nvSpPr>
-        <p:spPr>
-          <a:xfrm>
-            <a:off x="731520" y="3246120"/>
-            <a:ext cx="365760" cy="274320"/>
-          </a:xfrm>
-          <a:prstGeom prst="rect">
-            <a:avLst/>
-          </a:prstGeom>
-          <a:noFill/>
-          <a:ln/>
-        </p:spPr>
-        <p:txBody>
-          <a:bodyPr wrap="square" rtlCol="0" anchor="ctr"/>
-          <a:lstStyle/>
-          <a:p>
-            <a:pPr indent="0" marL="0">
-              <a:buNone/>
-            </a:pPr>
-            <a:r>
-              <a:rPr lang="en-US" sz="1800" dirty="0">
-                <a:solidFill>
-                  <a:srgbClr val="E0E0E0"/>
+          <p:cNvPr id="21" name="Shape 19"/>
+          <p:cNvSpPr/>
+          <p:nvPr/>
+        </p:nvSpPr>
+        <p:spPr>
+          <a:xfrm>
+            <a:off x="731520" y="4160520"/>
+            <a:ext cx="914400" cy="182880"/>
+          </a:xfrm>
+          <a:prstGeom prst="rect">
+            <a:avLst>
+              <a:gd name="adj" fmla="val 10000"/>
+            </a:avLst>
+          </a:prstGeom>
+          <a:solidFill>
+            <a:srgbClr val="F5F5F3"/>
+          </a:solidFill>
+          <a:ln/>
+        </p:spPr>
+      </p:sp>
+      <p:sp>
+        <p:nvSpPr>
+          <p:cNvPr id="22" name="Text 20"/>
+          <p:cNvSpPr/>
+          <p:nvPr/>
+        </p:nvSpPr>
+        <p:spPr>
+          <a:xfrm>
+            <a:off x="777240" y="4160520"/>
+            <a:ext cx="822960" cy="182880"/>
+          </a:xfrm>
+          <a:prstGeom prst="rect">
+            <a:avLst/>
+          </a:prstGeom>
+          <a:noFill/>
+          <a:ln/>
+        </p:spPr>
+        <p:txBody>
+          <a:bodyPr wrap="square" rtlCol="0" anchor="ctr"/>
+          <a:lstStyle/>
+          <a:p>
+            <a:pPr algn="ctr" indent="0" marL="0">
+              <a:buNone/>
+            </a:pPr>
+            <a:r>
+              <a:rPr lang="en-US" sz="650" dirty="0">
+                <a:solidFill>
+                  <a:srgbClr val="666666"/>
                 </a:solidFill>
                 <a:latin typeface="JetBrains Mono" pitchFamily="34" charset="0"/>
                 <a:ea typeface="JetBrains Mono" pitchFamily="34" charset="-122"/>
                 <a:cs typeface="JetBrains Mono" pitchFamily="34" charset="-120"/>
               </a:rPr>
-              <a:t>03</a:t>
-            </a:r>
-            <a:endParaRPr lang="en-US" sz="1800" dirty="0"/>
-          </a:p>
-        </p:txBody>
-      </p:sp>
-      <p:sp>
-        <p:nvSpPr>
-          <p:cNvPr id="22" name="Text 20"/>
-          <p:cNvSpPr/>
-          <p:nvPr/>
-        </p:nvSpPr>
-        <p:spPr>
-          <a:xfrm>
-            <a:off x="1188720" y="3246120"/>
-            <a:ext cx="10268712" cy="228600"/>
-          </a:xfrm>
-          <a:prstGeom prst="rect">
-            <a:avLst/>
-          </a:prstGeom>
-          <a:noFill/>
-          <a:ln/>
-        </p:spPr>
-        <p:txBody>
-          <a:bodyPr wrap="square" rtlCol="0" anchor="ctr"/>
-          <a:lstStyle/>
-          <a:p>
-            <a:pPr indent="0" marL="0">
-              <a:buNone/>
-            </a:pPr>
-            <a:r>
-              <a:rPr lang="en-US" sz="1100" b="1" dirty="0">
+              <a:t>CHIPS ACT</a:t>
+            </a:r>
+            <a:endParaRPr lang="en-US" sz="650" dirty="0"/>
+          </a:p>
+        </p:txBody>
+      </p:sp>
+      <p:sp>
+        <p:nvSpPr>
+          <p:cNvPr id="23" name="Text 21"/>
+          <p:cNvSpPr/>
+          <p:nvPr/>
+        </p:nvSpPr>
+        <p:spPr>
+          <a:xfrm>
+            <a:off x="731520" y="4416552"/>
+            <a:ext cx="10725912" cy="228600"/>
+          </a:xfrm>
+          <a:prstGeom prst="rect">
+            <a:avLst/>
+          </a:prstGeom>
+          <a:noFill/>
+          <a:ln/>
+        </p:spPr>
+        <p:txBody>
+          <a:bodyPr wrap="square" rtlCol="0" anchor="ctr"/>
+          <a:lstStyle/>
+          <a:p>
+            <a:pPr indent="0" marL="0">
+              <a:buNone/>
+            </a:pPr>
+            <a:r>
+              <a:rPr lang="en-US" sz="1300" b="1" dirty="0">
                 <a:solidFill>
                   <a:srgbClr val="1A1A1A"/>
                 </a:solidFill>
@@ -3994,48 +3871,9 @@
                 <a:ea typeface="HarmonyOS Sans SC" pitchFamily="34" charset="-122"/>
                 <a:cs typeface="HarmonyOS Sans SC" pitchFamily="34" charset="-120"/>
               </a:rPr>
-              <a:t>THz Carbon Nanotube Transistors — Nature Electronics</a:t>
-            </a:r>
-            <a:endParaRPr lang="en-US" sz="1100" dirty="0"/>
-          </a:p>
-        </p:txBody>
-      </p:sp>
-      <p:sp>
-        <p:nvSpPr>
-          <p:cNvPr id="23" name="Text 21"/>
-          <p:cNvSpPr/>
-          <p:nvPr/>
-        </p:nvSpPr>
-        <p:spPr>
-          <a:xfrm>
-            <a:off x="1188720" y="3474720"/>
-            <a:ext cx="2743200" cy="137160"/>
-          </a:xfrm>
-          <a:prstGeom prst="rect">
-            <a:avLst/>
-          </a:prstGeom>
-          <a:noFill/>
-          <a:ln/>
-        </p:spPr>
-        <p:txBody>
-          <a:bodyPr wrap="square" rtlCol="0" anchor="ctr"/>
-          <a:lstStyle/>
-          <a:p>
-            <a:pPr indent="0" marL="0">
-              <a:buNone/>
-            </a:pPr>
-            <a:r>
-              <a:rPr lang="en-US" sz="700" dirty="0">
-                <a:solidFill>
-                  <a:srgbClr val="999999"/>
-                </a:solidFill>
-                <a:latin typeface="JetBrains Mono" pitchFamily="34" charset="0"/>
-                <a:ea typeface="JetBrains Mono" pitchFamily="34" charset="-122"/>
-                <a:cs typeface="JetBrains Mono" pitchFamily="34" charset="-120"/>
-              </a:rPr>
-              <a:t>Nature Electronics · 2026</a:t>
-            </a:r>
-            <a:endParaRPr lang="en-US" sz="700" dirty="0"/>
+              <a:t>CHIPS Act 税收优惠面临到期</a:t>
+            </a:r>
+            <a:endParaRPr lang="en-US" sz="1300" dirty="0"/>
           </a:p>
         </p:txBody>
       </p:sp>
@@ -4047,8 +3885,8 @@
         </p:nvSpPr>
         <p:spPr>
           <a:xfrm>
-            <a:off x="1188720" y="3630168"/>
-            <a:ext cx="10268712" cy="274320"/>
+            <a:off x="731520" y="4663440"/>
+            <a:ext cx="10725912" cy="548640"/>
           </a:xfrm>
           <a:prstGeom prst="rect">
             <a:avLst/>
@@ -4062,22 +3900,22 @@
           <a:p>
             <a:pPr indent="0" marL="0">
               <a:lnSpc>
-                <a:spcPct val="140000"/>
+                <a:spcPct val="160000"/>
               </a:lnSpc>
               <a:buNone/>
             </a:pPr>
             <a:r>
-              <a:rPr lang="en-US" sz="900" dirty="0">
-                <a:solidFill>
-                  <a:srgbClr val="666666"/>
+              <a:rPr lang="en-US" sz="1000" dirty="0">
+                <a:solidFill>
+                  <a:srgbClr val="333333"/>
                 </a:solidFill>
                 <a:latin typeface="HarmonyOS Sans SC" pitchFamily="34" charset="0"/>
                 <a:ea typeface="HarmonyOS Sans SC" pitchFamily="34" charset="-122"/>
                 <a:cs typeface="HarmonyOS Sans SC" pitchFamily="34" charset="-120"/>
               </a:rPr>
-              <a:t>碳纳米管 MOSFET 截止频率突破 1 THz，后硅时代高频器件里程碑。</a:t>
-            </a:r>
-            <a:endParaRPr lang="en-US" sz="900" dirty="0"/>
+              <a:t>TSMC 宣布追加 $1,000 亿美国投资。但 Section 48D 先进制造投资税收抵免将于 2026 年到期，续期前景不明。</a:t>
+            </a:r>
+            <a:endParaRPr lang="en-US" sz="1000" dirty="0"/>
           </a:p>
         </p:txBody>
       </p:sp>
@@ -4089,7 +3927,7 @@
         </p:nvSpPr>
         <p:spPr>
           <a:xfrm>
-            <a:off x="731520" y="4069080"/>
+            <a:off x="731520" y="5394960"/>
             <a:ext cx="10725912" cy="0"/>
           </a:xfrm>
           <a:prstGeom prst="line">
@@ -4106,185 +3944,124 @@
       </p:sp>
       <p:sp>
         <p:nvSpPr>
-          <p:cNvPr id="26" name="Text 24"/>
-          <p:cNvSpPr/>
-          <p:nvPr/>
-        </p:nvSpPr>
-        <p:spPr>
-          <a:xfrm>
-            <a:off x="731520" y="4160520"/>
-            <a:ext cx="365760" cy="274320"/>
-          </a:xfrm>
-          <a:prstGeom prst="rect">
-            <a:avLst/>
-          </a:prstGeom>
-          <a:noFill/>
-          <a:ln/>
-        </p:spPr>
-        <p:txBody>
-          <a:bodyPr wrap="square" rtlCol="0" anchor="ctr"/>
-          <a:lstStyle/>
-          <a:p>
-            <a:pPr indent="0" marL="0">
-              <a:buNone/>
-            </a:pPr>
-            <a:r>
-              <a:rPr lang="en-US" sz="1800" dirty="0">
-                <a:solidFill>
-                  <a:srgbClr val="E0E0E0"/>
+          <p:cNvPr id="26" name="Shape 24"/>
+          <p:cNvSpPr/>
+          <p:nvPr/>
+        </p:nvSpPr>
+        <p:spPr>
+          <a:xfrm>
+            <a:off x="731520" y="5532120"/>
+            <a:ext cx="10725912" cy="731520"/>
+          </a:xfrm>
+          <a:prstGeom prst="rect">
+            <a:avLst/>
+          </a:prstGeom>
+          <a:solidFill>
+            <a:srgbClr val="F5F5F3"/>
+          </a:solidFill>
+          <a:ln/>
+        </p:spPr>
+      </p:sp>
+      <p:sp>
+        <p:nvSpPr>
+          <p:cNvPr id="27" name="Shape 25"/>
+          <p:cNvSpPr/>
+          <p:nvPr/>
+        </p:nvSpPr>
+        <p:spPr>
+          <a:xfrm>
+            <a:off x="731520" y="5532120"/>
+            <a:ext cx="36576" cy="731520"/>
+          </a:xfrm>
+          <a:prstGeom prst="rect">
+            <a:avLst/>
+          </a:prstGeom>
+          <a:solidFill>
+            <a:srgbClr val="141414"/>
+          </a:solidFill>
+          <a:ln/>
+        </p:spPr>
+      </p:sp>
+      <p:sp>
+        <p:nvSpPr>
+          <p:cNvPr id="28" name="Text 26"/>
+          <p:cNvSpPr/>
+          <p:nvPr/>
+        </p:nvSpPr>
+        <p:spPr>
+          <a:xfrm>
+            <a:off x="868680" y="5577840"/>
+            <a:ext cx="2743200" cy="137160"/>
+          </a:xfrm>
+          <a:prstGeom prst="rect">
+            <a:avLst/>
+          </a:prstGeom>
+          <a:noFill/>
+          <a:ln/>
+        </p:spPr>
+        <p:txBody>
+          <a:bodyPr wrap="square" rtlCol="0" anchor="ctr"/>
+          <a:lstStyle/>
+          <a:p>
+            <a:pPr indent="0" marL="0">
+              <a:buNone/>
+            </a:pPr>
+            <a:r>
+              <a:rPr lang="en-US" sz="650" dirty="0">
+                <a:solidFill>
+                  <a:srgbClr val="999999"/>
                 </a:solidFill>
                 <a:latin typeface="JetBrains Mono" pitchFamily="34" charset="0"/>
                 <a:ea typeface="JetBrains Mono" pitchFamily="34" charset="-122"/>
                 <a:cs typeface="JetBrains Mono" pitchFamily="34" charset="-120"/>
               </a:rPr>
-              <a:t>04</a:t>
-            </a:r>
-            <a:endParaRPr lang="en-US" sz="1800" dirty="0"/>
-          </a:p>
-        </p:txBody>
-      </p:sp>
-      <p:sp>
-        <p:nvSpPr>
-          <p:cNvPr id="27" name="Text 25"/>
-          <p:cNvSpPr/>
-          <p:nvPr/>
-        </p:nvSpPr>
-        <p:spPr>
-          <a:xfrm>
-            <a:off x="1188720" y="4160520"/>
-            <a:ext cx="10268712" cy="228600"/>
-          </a:xfrm>
-          <a:prstGeom prst="rect">
-            <a:avLst/>
-          </a:prstGeom>
-          <a:noFill/>
-          <a:ln/>
-        </p:spPr>
-        <p:txBody>
-          <a:bodyPr wrap="square" rtlCol="0" anchor="ctr"/>
-          <a:lstStyle/>
-          <a:p>
-            <a:pPr indent="0" marL="0">
-              <a:buNone/>
-            </a:pPr>
-            <a:r>
-              <a:rPr lang="en-US" sz="1100" b="1" dirty="0">
-                <a:solidFill>
-                  <a:srgbClr val="1A1A1A"/>
+              <a:t>FAB EXPANSION</a:t>
+            </a:r>
+            <a:endParaRPr lang="en-US" sz="650" dirty="0"/>
+          </a:p>
+        </p:txBody>
+      </p:sp>
+      <p:sp>
+        <p:nvSpPr>
+          <p:cNvPr id="29" name="Text 27"/>
+          <p:cNvSpPr/>
+          <p:nvPr/>
+        </p:nvSpPr>
+        <p:spPr>
+          <a:xfrm>
+            <a:off x="868680" y="5715000"/>
+            <a:ext cx="10451592" cy="502920"/>
+          </a:xfrm>
+          <a:prstGeom prst="rect">
+            <a:avLst/>
+          </a:prstGeom>
+          <a:noFill/>
+          <a:ln/>
+        </p:spPr>
+        <p:txBody>
+          <a:bodyPr wrap="square" rtlCol="0" anchor="ctr"/>
+          <a:lstStyle/>
+          <a:p>
+            <a:pPr indent="0" marL="0">
+              <a:lnSpc>
+                <a:spcPct val="150000"/>
+              </a:lnSpc>
+              <a:buNone/>
+            </a:pPr>
+            <a:r>
+              <a:rPr lang="en-US" sz="950" dirty="0">
+                <a:solidFill>
+                  <a:srgbClr val="333333"/>
                 </a:solidFill>
                 <a:latin typeface="HarmonyOS Sans SC" pitchFamily="34" charset="0"/>
                 <a:ea typeface="HarmonyOS Sans SC" pitchFamily="34" charset="-122"/>
                 <a:cs typeface="HarmonyOS Sans SC" pitchFamily="34" charset="-120"/>
               </a:rPr>
-              <a:t>MATCH Act: What It Means for Semiconductor Equipment Exports</a:t>
-            </a:r>
-            <a:endParaRPr lang="en-US" sz="1100" dirty="0"/>
-          </a:p>
-        </p:txBody>
-      </p:sp>
-      <p:sp>
-        <p:nvSpPr>
-          <p:cNvPr id="28" name="Text 26"/>
-          <p:cNvSpPr/>
-          <p:nvPr/>
-        </p:nvSpPr>
-        <p:spPr>
-          <a:xfrm>
-            <a:off x="1188720" y="4389120"/>
-            <a:ext cx="2743200" cy="137160"/>
-          </a:xfrm>
-          <a:prstGeom prst="rect">
-            <a:avLst/>
-          </a:prstGeom>
-          <a:noFill/>
-          <a:ln/>
-        </p:spPr>
-        <p:txBody>
-          <a:bodyPr wrap="square" rtlCol="0" anchor="ctr"/>
-          <a:lstStyle/>
-          <a:p>
-            <a:pPr indent="0" marL="0">
-              <a:buNone/>
-            </a:pPr>
-            <a:r>
-              <a:rPr lang="en-US" sz="700" dirty="0">
-                <a:solidFill>
-                  <a:srgbClr val="999999"/>
-                </a:solidFill>
-                <a:latin typeface="JetBrains Mono" pitchFamily="34" charset="0"/>
-                <a:ea typeface="JetBrains Mono" pitchFamily="34" charset="-122"/>
-                <a:cs typeface="JetBrains Mono" pitchFamily="34" charset="-120"/>
-              </a:rPr>
-              <a:t>Bloomberg · Apr 2, 2026</a:t>
-            </a:r>
-            <a:endParaRPr lang="en-US" sz="700" dirty="0"/>
-          </a:p>
-        </p:txBody>
-      </p:sp>
-      <p:sp>
-        <p:nvSpPr>
-          <p:cNvPr id="29" name="Text 27"/>
-          <p:cNvSpPr/>
-          <p:nvPr/>
-        </p:nvSpPr>
-        <p:spPr>
-          <a:xfrm>
-            <a:off x="1188720" y="4544568"/>
-            <a:ext cx="10268712" cy="274320"/>
-          </a:xfrm>
-          <a:prstGeom prst="rect">
-            <a:avLst/>
-          </a:prstGeom>
-          <a:noFill/>
-          <a:ln/>
-        </p:spPr>
-        <p:txBody>
-          <a:bodyPr wrap="square" rtlCol="0" anchor="ctr"/>
-          <a:lstStyle/>
-          <a:p>
-            <a:pPr indent="0" marL="0">
-              <a:lnSpc>
-                <a:spcPct val="140000"/>
-              </a:lnSpc>
-              <a:buNone/>
-            </a:pPr>
-            <a:r>
-              <a:rPr lang="en-US" sz="900" dirty="0">
-                <a:solidFill>
-                  <a:srgbClr val="666666"/>
-                </a:solidFill>
-                <a:latin typeface="HarmonyOS Sans SC" pitchFamily="34" charset="0"/>
-                <a:ea typeface="HarmonyOS Sans SC" pitchFamily="34" charset="-122"/>
-                <a:cs typeface="HarmonyOS Sans SC" pitchFamily="34" charset="-120"/>
-              </a:rPr>
-              <a:t>法案全文解读与影响分析，重点关注对 ASML DUV 业务及日荷盟友的连锁反应。</a:t>
-            </a:r>
-            <a:endParaRPr lang="en-US" sz="900" dirty="0"/>
-          </a:p>
-        </p:txBody>
-      </p:sp>
-      <p:sp>
-        <p:nvSpPr>
-          <p:cNvPr id="30" name="Shape 28"/>
-          <p:cNvSpPr/>
-          <p:nvPr/>
-        </p:nvSpPr>
-        <p:spPr>
-          <a:xfrm>
-            <a:off x="731520" y="4983480"/>
-            <a:ext cx="10725912" cy="0"/>
-          </a:xfrm>
-          <a:prstGeom prst="line">
-            <a:avLst/>
-          </a:prstGeom>
-          <a:noFill/>
-          <a:ln w="3810">
-            <a:solidFill>
-              <a:srgbClr val="E0E0E0"/>
-            </a:solidFill>
-            <a:prstDash val="solid"/>
-          </a:ln>
-        </p:spPr>
+              <a:t>TSMC 亚利桑那规模扩大至最多 12 座晶圆厂 + 4 座先进封装厂；台湾同步推进 10 座新厂。全球 2025 年新开工 18 个晶圆厂项目（3 座 200mm + 15 座 300mm），美洲和日本各 4 个领跑。</a:t>
+            </a:r>
+            <a:endParaRPr lang="en-US" sz="950" dirty="0"/>
+          </a:p>
+        </p:txBody>
       </p:sp>
     </p:spTree>
   </p:cSld>
@@ -4507,7 +4284,1079 @@
                 <a:ea typeface="JetBrains Mono" pitchFamily="34" charset="-122"/>
                 <a:cs typeface="JetBrains Mono" pitchFamily="34" charset="-120"/>
               </a:rPr>
-              <a:t>12 / 12</a:t>
+              <a:t>12 / 13</a:t>
+            </a:r>
+            <a:endParaRPr lang="en-US" sz="650" dirty="0"/>
+          </a:p>
+        </p:txBody>
+      </p:sp>
+      <p:sp>
+        <p:nvSpPr>
+          <p:cNvPr id="8" name="Text 6"/>
+          <p:cNvSpPr/>
+          <p:nvPr/>
+        </p:nvSpPr>
+        <p:spPr>
+          <a:xfrm>
+            <a:off x="731520" y="640080"/>
+            <a:ext cx="457200" cy="182880"/>
+          </a:xfrm>
+          <a:prstGeom prst="rect">
+            <a:avLst/>
+          </a:prstGeom>
+          <a:noFill/>
+          <a:ln/>
+        </p:spPr>
+        <p:txBody>
+          <a:bodyPr wrap="square" rtlCol="0" anchor="ctr"/>
+          <a:lstStyle/>
+          <a:p>
+            <a:pPr indent="0" marL="0">
+              <a:buNone/>
+            </a:pPr>
+            <a:r>
+              <a:rPr lang="en-US" sz="700" dirty="0">
+                <a:solidFill>
+                  <a:srgbClr val="C0392B"/>
+                </a:solidFill>
+                <a:latin typeface="JetBrains Mono" pitchFamily="34" charset="0"/>
+                <a:ea typeface="JetBrains Mono" pitchFamily="34" charset="-122"/>
+                <a:cs typeface="JetBrains Mono" pitchFamily="34" charset="-120"/>
+              </a:rPr>
+              <a:t>10</a:t>
+            </a:r>
+            <a:endParaRPr lang="en-US" sz="700" dirty="0"/>
+          </a:p>
+        </p:txBody>
+      </p:sp>
+      <p:sp>
+        <p:nvSpPr>
+          <p:cNvPr id="9" name="Text 7"/>
+          <p:cNvSpPr/>
+          <p:nvPr/>
+        </p:nvSpPr>
+        <p:spPr>
+          <a:xfrm>
+            <a:off x="731520" y="804672"/>
+            <a:ext cx="10725912" cy="365760"/>
+          </a:xfrm>
+          <a:prstGeom prst="rect">
+            <a:avLst/>
+          </a:prstGeom>
+          <a:noFill/>
+          <a:ln/>
+        </p:spPr>
+        <p:txBody>
+          <a:bodyPr wrap="square" rtlCol="0" anchor="ctr"/>
+          <a:lstStyle/>
+          <a:p>
+            <a:pPr indent="0" marL="0">
+              <a:buNone/>
+            </a:pPr>
+            <a:r>
+              <a:rPr lang="en-US" sz="2200" b="1" dirty="0">
+                <a:solidFill>
+                  <a:srgbClr val="141414"/>
+                </a:solidFill>
+                <a:latin typeface="HarmonyOS Sans SC" pitchFamily="34" charset="0"/>
+                <a:ea typeface="HarmonyOS Sans SC" pitchFamily="34" charset="-122"/>
+                <a:cs typeface="HarmonyOS Sans SC" pitchFamily="34" charset="-120"/>
+              </a:rPr>
+              <a:t>值得一读</a:t>
+            </a:r>
+            <a:endParaRPr lang="en-US" sz="2200" dirty="0"/>
+          </a:p>
+        </p:txBody>
+      </p:sp>
+      <p:sp>
+        <p:nvSpPr>
+          <p:cNvPr id="10" name="Text 8"/>
+          <p:cNvSpPr/>
+          <p:nvPr/>
+        </p:nvSpPr>
+        <p:spPr>
+          <a:xfrm>
+            <a:off x="731520" y="1143000"/>
+            <a:ext cx="10725912" cy="182880"/>
+          </a:xfrm>
+          <a:prstGeom prst="rect">
+            <a:avLst/>
+          </a:prstGeom>
+          <a:noFill/>
+          <a:ln/>
+        </p:spPr>
+        <p:txBody>
+          <a:bodyPr wrap="square" rtlCol="0" anchor="ctr"/>
+          <a:lstStyle/>
+          <a:p>
+            <a:pPr indent="0" marL="0">
+              <a:buNone/>
+            </a:pPr>
+            <a:r>
+              <a:rPr lang="en-US" sz="700" dirty="0">
+                <a:solidFill>
+                  <a:srgbClr val="999999"/>
+                </a:solidFill>
+                <a:latin typeface="JetBrains Mono" pitchFamily="34" charset="0"/>
+                <a:ea typeface="JetBrains Mono" pitchFamily="34" charset="-122"/>
+                <a:cs typeface="JetBrains Mono" pitchFamily="34" charset="-120"/>
+              </a:rPr>
+              <a:t>WORTH READING</a:t>
+            </a:r>
+            <a:endParaRPr lang="en-US" sz="700" dirty="0"/>
+          </a:p>
+        </p:txBody>
+      </p:sp>
+      <p:sp>
+        <p:nvSpPr>
+          <p:cNvPr id="11" name="Text 9"/>
+          <p:cNvSpPr/>
+          <p:nvPr/>
+        </p:nvSpPr>
+        <p:spPr>
+          <a:xfrm>
+            <a:off x="731520" y="1417320"/>
+            <a:ext cx="365760" cy="274320"/>
+          </a:xfrm>
+          <a:prstGeom prst="rect">
+            <a:avLst/>
+          </a:prstGeom>
+          <a:noFill/>
+          <a:ln/>
+        </p:spPr>
+        <p:txBody>
+          <a:bodyPr wrap="square" rtlCol="0" anchor="ctr"/>
+          <a:lstStyle/>
+          <a:p>
+            <a:pPr indent="0" marL="0">
+              <a:buNone/>
+            </a:pPr>
+            <a:r>
+              <a:rPr lang="en-US" sz="1800" dirty="0">
+                <a:solidFill>
+                  <a:srgbClr val="E0E0E0"/>
+                </a:solidFill>
+                <a:latin typeface="JetBrains Mono" pitchFamily="34" charset="0"/>
+                <a:ea typeface="JetBrains Mono" pitchFamily="34" charset="-122"/>
+                <a:cs typeface="JetBrains Mono" pitchFamily="34" charset="-120"/>
+              </a:rPr>
+              <a:t>01</a:t>
+            </a:r>
+            <a:endParaRPr lang="en-US" sz="1800" dirty="0"/>
+          </a:p>
+        </p:txBody>
+      </p:sp>
+      <p:sp>
+        <p:nvSpPr>
+          <p:cNvPr id="12" name="Text 10"/>
+          <p:cNvSpPr/>
+          <p:nvPr/>
+        </p:nvSpPr>
+        <p:spPr>
+          <a:xfrm>
+            <a:off x="1188720" y="1417320"/>
+            <a:ext cx="10268712" cy="228600"/>
+          </a:xfrm>
+          <a:prstGeom prst="rect">
+            <a:avLst/>
+          </a:prstGeom>
+          <a:noFill/>
+          <a:ln/>
+        </p:spPr>
+        <p:txBody>
+          <a:bodyPr wrap="square" rtlCol="0" anchor="ctr"/>
+          <a:lstStyle/>
+          <a:p>
+            <a:pPr indent="0" marL="0">
+              <a:buNone/>
+            </a:pPr>
+            <a:r>
+              <a:rPr lang="en-US" sz="1100" b="1" dirty="0">
+                <a:solidFill>
+                  <a:srgbClr val="1A1A1A"/>
+                </a:solidFill>
+                <a:latin typeface="HarmonyOS Sans SC" pitchFamily="34" charset="0"/>
+                <a:ea typeface="HarmonyOS Sans SC" pitchFamily="34" charset="-122"/>
+                <a:cs typeface="HarmonyOS Sans SC" pitchFamily="34" charset="-120"/>
+              </a:rPr>
+              <a:t>SEMI: Global 300mm Fab Equipment Spending to Reach $151B by 2027</a:t>
+            </a:r>
+            <a:endParaRPr lang="en-US" sz="1100" dirty="0"/>
+          </a:p>
+        </p:txBody>
+      </p:sp>
+      <p:sp>
+        <p:nvSpPr>
+          <p:cNvPr id="13" name="Text 11"/>
+          <p:cNvSpPr/>
+          <p:nvPr/>
+        </p:nvSpPr>
+        <p:spPr>
+          <a:xfrm>
+            <a:off x="1188720" y="1645920"/>
+            <a:ext cx="2743200" cy="137160"/>
+          </a:xfrm>
+          <a:prstGeom prst="rect">
+            <a:avLst/>
+          </a:prstGeom>
+          <a:noFill/>
+          <a:ln/>
+        </p:spPr>
+        <p:txBody>
+          <a:bodyPr wrap="square" rtlCol="0" anchor="ctr"/>
+          <a:lstStyle/>
+          <a:p>
+            <a:pPr indent="0" marL="0">
+              <a:buNone/>
+            </a:pPr>
+            <a:r>
+              <a:rPr lang="en-US" sz="700" dirty="0">
+                <a:solidFill>
+                  <a:srgbClr val="999999"/>
+                </a:solidFill>
+                <a:latin typeface="JetBrains Mono" pitchFamily="34" charset="0"/>
+                <a:ea typeface="JetBrains Mono" pitchFamily="34" charset="-122"/>
+                <a:cs typeface="JetBrains Mono" pitchFamily="34" charset="-120"/>
+              </a:rPr>
+              <a:t>SEMI.org · Apr 8, 2026</a:t>
+            </a:r>
+            <a:endParaRPr lang="en-US" sz="700" dirty="0"/>
+          </a:p>
+        </p:txBody>
+      </p:sp>
+      <p:sp>
+        <p:nvSpPr>
+          <p:cNvPr id="14" name="Text 12"/>
+          <p:cNvSpPr/>
+          <p:nvPr/>
+        </p:nvSpPr>
+        <p:spPr>
+          <a:xfrm>
+            <a:off x="1188720" y="1801368"/>
+            <a:ext cx="10268712" cy="274320"/>
+          </a:xfrm>
+          <a:prstGeom prst="rect">
+            <a:avLst/>
+          </a:prstGeom>
+          <a:noFill/>
+          <a:ln/>
+        </p:spPr>
+        <p:txBody>
+          <a:bodyPr wrap="square" rtlCol="0" anchor="ctr"/>
+          <a:lstStyle/>
+          <a:p>
+            <a:pPr indent="0" marL="0">
+              <a:lnSpc>
+                <a:spcPct val="140000"/>
+              </a:lnSpc>
+              <a:buNone/>
+            </a:pPr>
+            <a:r>
+              <a:rPr lang="en-US" sz="900" dirty="0">
+                <a:solidFill>
+                  <a:srgbClr val="666666"/>
+                </a:solidFill>
+                <a:latin typeface="HarmonyOS Sans SC" pitchFamily="34" charset="0"/>
+                <a:ea typeface="HarmonyOS Sans SC" pitchFamily="34" charset="-122"/>
+                <a:cs typeface="HarmonyOS Sans SC" pitchFamily="34" charset="-120"/>
+              </a:rPr>
+              <a:t>SEMI 最新预测报告，详细拆解各地区、各环节设备投资趋势。</a:t>
+            </a:r>
+            <a:endParaRPr lang="en-US" sz="900" dirty="0"/>
+          </a:p>
+        </p:txBody>
+      </p:sp>
+      <p:sp>
+        <p:nvSpPr>
+          <p:cNvPr id="15" name="Shape 13"/>
+          <p:cNvSpPr/>
+          <p:nvPr/>
+        </p:nvSpPr>
+        <p:spPr>
+          <a:xfrm>
+            <a:off x="731520" y="2240280"/>
+            <a:ext cx="10725912" cy="0"/>
+          </a:xfrm>
+          <a:prstGeom prst="line">
+            <a:avLst/>
+          </a:prstGeom>
+          <a:noFill/>
+          <a:ln w="3810">
+            <a:solidFill>
+              <a:srgbClr val="E0E0E0"/>
+            </a:solidFill>
+            <a:prstDash val="solid"/>
+          </a:ln>
+        </p:spPr>
+      </p:sp>
+      <p:sp>
+        <p:nvSpPr>
+          <p:cNvPr id="16" name="Text 14"/>
+          <p:cNvSpPr/>
+          <p:nvPr/>
+        </p:nvSpPr>
+        <p:spPr>
+          <a:xfrm>
+            <a:off x="731520" y="2331720"/>
+            <a:ext cx="365760" cy="274320"/>
+          </a:xfrm>
+          <a:prstGeom prst="rect">
+            <a:avLst/>
+          </a:prstGeom>
+          <a:noFill/>
+          <a:ln/>
+        </p:spPr>
+        <p:txBody>
+          <a:bodyPr wrap="square" rtlCol="0" anchor="ctr"/>
+          <a:lstStyle/>
+          <a:p>
+            <a:pPr indent="0" marL="0">
+              <a:buNone/>
+            </a:pPr>
+            <a:r>
+              <a:rPr lang="en-US" sz="1800" dirty="0">
+                <a:solidFill>
+                  <a:srgbClr val="E0E0E0"/>
+                </a:solidFill>
+                <a:latin typeface="JetBrains Mono" pitchFamily="34" charset="0"/>
+                <a:ea typeface="JetBrains Mono" pitchFamily="34" charset="-122"/>
+                <a:cs typeface="JetBrains Mono" pitchFamily="34" charset="-120"/>
+              </a:rPr>
+              <a:t>02</a:t>
+            </a:r>
+            <a:endParaRPr lang="en-US" sz="1800" dirty="0"/>
+          </a:p>
+        </p:txBody>
+      </p:sp>
+      <p:sp>
+        <p:nvSpPr>
+          <p:cNvPr id="17" name="Text 15"/>
+          <p:cNvSpPr/>
+          <p:nvPr/>
+        </p:nvSpPr>
+        <p:spPr>
+          <a:xfrm>
+            <a:off x="1188720" y="2331720"/>
+            <a:ext cx="10268712" cy="228600"/>
+          </a:xfrm>
+          <a:prstGeom prst="rect">
+            <a:avLst/>
+          </a:prstGeom>
+          <a:noFill/>
+          <a:ln/>
+        </p:spPr>
+        <p:txBody>
+          <a:bodyPr wrap="square" rtlCol="0" anchor="ctr"/>
+          <a:lstStyle/>
+          <a:p>
+            <a:pPr indent="0" marL="0">
+              <a:buNone/>
+            </a:pPr>
+            <a:r>
+              <a:rPr lang="en-US" sz="1100" b="1" dirty="0">
+                <a:solidFill>
+                  <a:srgbClr val="1A1A1A"/>
+                </a:solidFill>
+                <a:latin typeface="HarmonyOS Sans SC" pitchFamily="34" charset="0"/>
+                <a:ea typeface="HarmonyOS Sans SC" pitchFamily="34" charset="-122"/>
+                <a:cs typeface="HarmonyOS Sans SC" pitchFamily="34" charset="-120"/>
+              </a:rPr>
+              <a:t>Backside Power Delivery Nears Production</a:t>
+            </a:r>
+            <a:endParaRPr lang="en-US" sz="1100" dirty="0"/>
+          </a:p>
+        </p:txBody>
+      </p:sp>
+      <p:sp>
+        <p:nvSpPr>
+          <p:cNvPr id="18" name="Text 16"/>
+          <p:cNvSpPr/>
+          <p:nvPr/>
+        </p:nvSpPr>
+        <p:spPr>
+          <a:xfrm>
+            <a:off x="1188720" y="2560320"/>
+            <a:ext cx="2743200" cy="137160"/>
+          </a:xfrm>
+          <a:prstGeom prst="rect">
+            <a:avLst/>
+          </a:prstGeom>
+          <a:noFill/>
+          <a:ln/>
+        </p:spPr>
+        <p:txBody>
+          <a:bodyPr wrap="square" rtlCol="0" anchor="ctr"/>
+          <a:lstStyle/>
+          <a:p>
+            <a:pPr indent="0" marL="0">
+              <a:buNone/>
+            </a:pPr>
+            <a:r>
+              <a:rPr lang="en-US" sz="700" dirty="0">
+                <a:solidFill>
+                  <a:srgbClr val="999999"/>
+                </a:solidFill>
+                <a:latin typeface="JetBrains Mono" pitchFamily="34" charset="0"/>
+                <a:ea typeface="JetBrains Mono" pitchFamily="34" charset="-122"/>
+                <a:cs typeface="JetBrains Mono" pitchFamily="34" charset="-120"/>
+              </a:rPr>
+              <a:t>SemiEngineering · Mar 2026</a:t>
+            </a:r>
+            <a:endParaRPr lang="en-US" sz="700" dirty="0"/>
+          </a:p>
+        </p:txBody>
+      </p:sp>
+      <p:sp>
+        <p:nvSpPr>
+          <p:cNvPr id="19" name="Text 17"/>
+          <p:cNvSpPr/>
+          <p:nvPr/>
+        </p:nvSpPr>
+        <p:spPr>
+          <a:xfrm>
+            <a:off x="1188720" y="2715768"/>
+            <a:ext cx="10268712" cy="274320"/>
+          </a:xfrm>
+          <a:prstGeom prst="rect">
+            <a:avLst/>
+          </a:prstGeom>
+          <a:noFill/>
+          <a:ln/>
+        </p:spPr>
+        <p:txBody>
+          <a:bodyPr wrap="square" rtlCol="0" anchor="ctr"/>
+          <a:lstStyle/>
+          <a:p>
+            <a:pPr indent="0" marL="0">
+              <a:lnSpc>
+                <a:spcPct val="140000"/>
+              </a:lnSpc>
+              <a:buNone/>
+            </a:pPr>
+            <a:r>
+              <a:rPr lang="en-US" sz="900" dirty="0">
+                <a:solidFill>
+                  <a:srgbClr val="666666"/>
+                </a:solidFill>
+                <a:latin typeface="HarmonyOS Sans SC" pitchFamily="34" charset="0"/>
+                <a:ea typeface="HarmonyOS Sans SC" pitchFamily="34" charset="-122"/>
+                <a:cs typeface="HarmonyOS Sans SC" pitchFamily="34" charset="-120"/>
+              </a:rPr>
+              <a:t>深度解析背面供电技术的量产挑战，涵盖 TSMC、Intel、Samsung 的不同技术路线。</a:t>
+            </a:r>
+            <a:endParaRPr lang="en-US" sz="900" dirty="0"/>
+          </a:p>
+        </p:txBody>
+      </p:sp>
+      <p:sp>
+        <p:nvSpPr>
+          <p:cNvPr id="20" name="Shape 18"/>
+          <p:cNvSpPr/>
+          <p:nvPr/>
+        </p:nvSpPr>
+        <p:spPr>
+          <a:xfrm>
+            <a:off x="731520" y="3154680"/>
+            <a:ext cx="10725912" cy="0"/>
+          </a:xfrm>
+          <a:prstGeom prst="line">
+            <a:avLst/>
+          </a:prstGeom>
+          <a:noFill/>
+          <a:ln w="3810">
+            <a:solidFill>
+              <a:srgbClr val="E0E0E0"/>
+            </a:solidFill>
+            <a:prstDash val="solid"/>
+          </a:ln>
+        </p:spPr>
+      </p:sp>
+      <p:sp>
+        <p:nvSpPr>
+          <p:cNvPr id="21" name="Text 19"/>
+          <p:cNvSpPr/>
+          <p:nvPr/>
+        </p:nvSpPr>
+        <p:spPr>
+          <a:xfrm>
+            <a:off x="731520" y="3246120"/>
+            <a:ext cx="365760" cy="274320"/>
+          </a:xfrm>
+          <a:prstGeom prst="rect">
+            <a:avLst/>
+          </a:prstGeom>
+          <a:noFill/>
+          <a:ln/>
+        </p:spPr>
+        <p:txBody>
+          <a:bodyPr wrap="square" rtlCol="0" anchor="ctr"/>
+          <a:lstStyle/>
+          <a:p>
+            <a:pPr indent="0" marL="0">
+              <a:buNone/>
+            </a:pPr>
+            <a:r>
+              <a:rPr lang="en-US" sz="1800" dirty="0">
+                <a:solidFill>
+                  <a:srgbClr val="E0E0E0"/>
+                </a:solidFill>
+                <a:latin typeface="JetBrains Mono" pitchFamily="34" charset="0"/>
+                <a:ea typeface="JetBrains Mono" pitchFamily="34" charset="-122"/>
+                <a:cs typeface="JetBrains Mono" pitchFamily="34" charset="-120"/>
+              </a:rPr>
+              <a:t>03</a:t>
+            </a:r>
+            <a:endParaRPr lang="en-US" sz="1800" dirty="0"/>
+          </a:p>
+        </p:txBody>
+      </p:sp>
+      <p:sp>
+        <p:nvSpPr>
+          <p:cNvPr id="22" name="Text 20"/>
+          <p:cNvSpPr/>
+          <p:nvPr/>
+        </p:nvSpPr>
+        <p:spPr>
+          <a:xfrm>
+            <a:off x="1188720" y="3246120"/>
+            <a:ext cx="10268712" cy="228600"/>
+          </a:xfrm>
+          <a:prstGeom prst="rect">
+            <a:avLst/>
+          </a:prstGeom>
+          <a:noFill/>
+          <a:ln/>
+        </p:spPr>
+        <p:txBody>
+          <a:bodyPr wrap="square" rtlCol="0" anchor="ctr"/>
+          <a:lstStyle/>
+          <a:p>
+            <a:pPr indent="0" marL="0">
+              <a:buNone/>
+            </a:pPr>
+            <a:r>
+              <a:rPr lang="en-US" sz="1100" b="1" dirty="0">
+                <a:solidFill>
+                  <a:srgbClr val="1A1A1A"/>
+                </a:solidFill>
+                <a:latin typeface="HarmonyOS Sans SC" pitchFamily="34" charset="0"/>
+                <a:ea typeface="HarmonyOS Sans SC" pitchFamily="34" charset="-122"/>
+                <a:cs typeface="HarmonyOS Sans SC" pitchFamily="34" charset="-120"/>
+              </a:rPr>
+              <a:t>THz Carbon Nanotube Transistors — Nature Electronics</a:t>
+            </a:r>
+            <a:endParaRPr lang="en-US" sz="1100" dirty="0"/>
+          </a:p>
+        </p:txBody>
+      </p:sp>
+      <p:sp>
+        <p:nvSpPr>
+          <p:cNvPr id="23" name="Text 21"/>
+          <p:cNvSpPr/>
+          <p:nvPr/>
+        </p:nvSpPr>
+        <p:spPr>
+          <a:xfrm>
+            <a:off x="1188720" y="3474720"/>
+            <a:ext cx="2743200" cy="137160"/>
+          </a:xfrm>
+          <a:prstGeom prst="rect">
+            <a:avLst/>
+          </a:prstGeom>
+          <a:noFill/>
+          <a:ln/>
+        </p:spPr>
+        <p:txBody>
+          <a:bodyPr wrap="square" rtlCol="0" anchor="ctr"/>
+          <a:lstStyle/>
+          <a:p>
+            <a:pPr indent="0" marL="0">
+              <a:buNone/>
+            </a:pPr>
+            <a:r>
+              <a:rPr lang="en-US" sz="700" dirty="0">
+                <a:solidFill>
+                  <a:srgbClr val="999999"/>
+                </a:solidFill>
+                <a:latin typeface="JetBrains Mono" pitchFamily="34" charset="0"/>
+                <a:ea typeface="JetBrains Mono" pitchFamily="34" charset="-122"/>
+                <a:cs typeface="JetBrains Mono" pitchFamily="34" charset="-120"/>
+              </a:rPr>
+              <a:t>Nature Electronics · 2026</a:t>
+            </a:r>
+            <a:endParaRPr lang="en-US" sz="700" dirty="0"/>
+          </a:p>
+        </p:txBody>
+      </p:sp>
+      <p:sp>
+        <p:nvSpPr>
+          <p:cNvPr id="24" name="Text 22"/>
+          <p:cNvSpPr/>
+          <p:nvPr/>
+        </p:nvSpPr>
+        <p:spPr>
+          <a:xfrm>
+            <a:off x="1188720" y="3630168"/>
+            <a:ext cx="10268712" cy="274320"/>
+          </a:xfrm>
+          <a:prstGeom prst="rect">
+            <a:avLst/>
+          </a:prstGeom>
+          <a:noFill/>
+          <a:ln/>
+        </p:spPr>
+        <p:txBody>
+          <a:bodyPr wrap="square" rtlCol="0" anchor="ctr"/>
+          <a:lstStyle/>
+          <a:p>
+            <a:pPr indent="0" marL="0">
+              <a:lnSpc>
+                <a:spcPct val="140000"/>
+              </a:lnSpc>
+              <a:buNone/>
+            </a:pPr>
+            <a:r>
+              <a:rPr lang="en-US" sz="900" dirty="0">
+                <a:solidFill>
+                  <a:srgbClr val="666666"/>
+                </a:solidFill>
+                <a:latin typeface="HarmonyOS Sans SC" pitchFamily="34" charset="0"/>
+                <a:ea typeface="HarmonyOS Sans SC" pitchFamily="34" charset="-122"/>
+                <a:cs typeface="HarmonyOS Sans SC" pitchFamily="34" charset="-120"/>
+              </a:rPr>
+              <a:t>碳纳米管 MOSFET 截止频率突破 1 THz，后硅时代高频器件里程碑。</a:t>
+            </a:r>
+            <a:endParaRPr lang="en-US" sz="900" dirty="0"/>
+          </a:p>
+        </p:txBody>
+      </p:sp>
+      <p:sp>
+        <p:nvSpPr>
+          <p:cNvPr id="25" name="Shape 23"/>
+          <p:cNvSpPr/>
+          <p:nvPr/>
+        </p:nvSpPr>
+        <p:spPr>
+          <a:xfrm>
+            <a:off x="731520" y="4069080"/>
+            <a:ext cx="10725912" cy="0"/>
+          </a:xfrm>
+          <a:prstGeom prst="line">
+            <a:avLst/>
+          </a:prstGeom>
+          <a:noFill/>
+          <a:ln w="3810">
+            <a:solidFill>
+              <a:srgbClr val="E0E0E0"/>
+            </a:solidFill>
+            <a:prstDash val="solid"/>
+          </a:ln>
+        </p:spPr>
+      </p:sp>
+      <p:sp>
+        <p:nvSpPr>
+          <p:cNvPr id="26" name="Text 24"/>
+          <p:cNvSpPr/>
+          <p:nvPr/>
+        </p:nvSpPr>
+        <p:spPr>
+          <a:xfrm>
+            <a:off x="731520" y="4160520"/>
+            <a:ext cx="365760" cy="274320"/>
+          </a:xfrm>
+          <a:prstGeom prst="rect">
+            <a:avLst/>
+          </a:prstGeom>
+          <a:noFill/>
+          <a:ln/>
+        </p:spPr>
+        <p:txBody>
+          <a:bodyPr wrap="square" rtlCol="0" anchor="ctr"/>
+          <a:lstStyle/>
+          <a:p>
+            <a:pPr indent="0" marL="0">
+              <a:buNone/>
+            </a:pPr>
+            <a:r>
+              <a:rPr lang="en-US" sz="1800" dirty="0">
+                <a:solidFill>
+                  <a:srgbClr val="E0E0E0"/>
+                </a:solidFill>
+                <a:latin typeface="JetBrains Mono" pitchFamily="34" charset="0"/>
+                <a:ea typeface="JetBrains Mono" pitchFamily="34" charset="-122"/>
+                <a:cs typeface="JetBrains Mono" pitchFamily="34" charset="-120"/>
+              </a:rPr>
+              <a:t>04</a:t>
+            </a:r>
+            <a:endParaRPr lang="en-US" sz="1800" dirty="0"/>
+          </a:p>
+        </p:txBody>
+      </p:sp>
+      <p:sp>
+        <p:nvSpPr>
+          <p:cNvPr id="27" name="Text 25"/>
+          <p:cNvSpPr/>
+          <p:nvPr/>
+        </p:nvSpPr>
+        <p:spPr>
+          <a:xfrm>
+            <a:off x="1188720" y="4160520"/>
+            <a:ext cx="10268712" cy="228600"/>
+          </a:xfrm>
+          <a:prstGeom prst="rect">
+            <a:avLst/>
+          </a:prstGeom>
+          <a:noFill/>
+          <a:ln/>
+        </p:spPr>
+        <p:txBody>
+          <a:bodyPr wrap="square" rtlCol="0" anchor="ctr"/>
+          <a:lstStyle/>
+          <a:p>
+            <a:pPr indent="0" marL="0">
+              <a:buNone/>
+            </a:pPr>
+            <a:r>
+              <a:rPr lang="en-US" sz="1100" b="1" dirty="0">
+                <a:solidFill>
+                  <a:srgbClr val="1A1A1A"/>
+                </a:solidFill>
+                <a:latin typeface="HarmonyOS Sans SC" pitchFamily="34" charset="0"/>
+                <a:ea typeface="HarmonyOS Sans SC" pitchFamily="34" charset="-122"/>
+                <a:cs typeface="HarmonyOS Sans SC" pitchFamily="34" charset="-120"/>
+              </a:rPr>
+              <a:t>MATCH Act: What It Means for Semiconductor Equipment Exports</a:t>
+            </a:r>
+            <a:endParaRPr lang="en-US" sz="1100" dirty="0"/>
+          </a:p>
+        </p:txBody>
+      </p:sp>
+      <p:sp>
+        <p:nvSpPr>
+          <p:cNvPr id="28" name="Text 26"/>
+          <p:cNvSpPr/>
+          <p:nvPr/>
+        </p:nvSpPr>
+        <p:spPr>
+          <a:xfrm>
+            <a:off x="1188720" y="4389120"/>
+            <a:ext cx="2743200" cy="137160"/>
+          </a:xfrm>
+          <a:prstGeom prst="rect">
+            <a:avLst/>
+          </a:prstGeom>
+          <a:noFill/>
+          <a:ln/>
+        </p:spPr>
+        <p:txBody>
+          <a:bodyPr wrap="square" rtlCol="0" anchor="ctr"/>
+          <a:lstStyle/>
+          <a:p>
+            <a:pPr indent="0" marL="0">
+              <a:buNone/>
+            </a:pPr>
+            <a:r>
+              <a:rPr lang="en-US" sz="700" dirty="0">
+                <a:solidFill>
+                  <a:srgbClr val="999999"/>
+                </a:solidFill>
+                <a:latin typeface="JetBrains Mono" pitchFamily="34" charset="0"/>
+                <a:ea typeface="JetBrains Mono" pitchFamily="34" charset="-122"/>
+                <a:cs typeface="JetBrains Mono" pitchFamily="34" charset="-120"/>
+              </a:rPr>
+              <a:t>Bloomberg · Apr 2, 2026</a:t>
+            </a:r>
+            <a:endParaRPr lang="en-US" sz="700" dirty="0"/>
+          </a:p>
+        </p:txBody>
+      </p:sp>
+      <p:sp>
+        <p:nvSpPr>
+          <p:cNvPr id="29" name="Text 27"/>
+          <p:cNvSpPr/>
+          <p:nvPr/>
+        </p:nvSpPr>
+        <p:spPr>
+          <a:xfrm>
+            <a:off x="1188720" y="4544568"/>
+            <a:ext cx="10268712" cy="274320"/>
+          </a:xfrm>
+          <a:prstGeom prst="rect">
+            <a:avLst/>
+          </a:prstGeom>
+          <a:noFill/>
+          <a:ln/>
+        </p:spPr>
+        <p:txBody>
+          <a:bodyPr wrap="square" rtlCol="0" anchor="ctr"/>
+          <a:lstStyle/>
+          <a:p>
+            <a:pPr indent="0" marL="0">
+              <a:lnSpc>
+                <a:spcPct val="140000"/>
+              </a:lnSpc>
+              <a:buNone/>
+            </a:pPr>
+            <a:r>
+              <a:rPr lang="en-US" sz="900" dirty="0">
+                <a:solidFill>
+                  <a:srgbClr val="666666"/>
+                </a:solidFill>
+                <a:latin typeface="HarmonyOS Sans SC" pitchFamily="34" charset="0"/>
+                <a:ea typeface="HarmonyOS Sans SC" pitchFamily="34" charset="-122"/>
+                <a:cs typeface="HarmonyOS Sans SC" pitchFamily="34" charset="-120"/>
+              </a:rPr>
+              <a:t>法案全文解读与影响分析，重点关注对 ASML DUV 业务及日荷盟友的连锁反应。</a:t>
+            </a:r>
+            <a:endParaRPr lang="en-US" sz="900" dirty="0"/>
+          </a:p>
+        </p:txBody>
+      </p:sp>
+      <p:sp>
+        <p:nvSpPr>
+          <p:cNvPr id="30" name="Shape 28"/>
+          <p:cNvSpPr/>
+          <p:nvPr/>
+        </p:nvSpPr>
+        <p:spPr>
+          <a:xfrm>
+            <a:off x="731520" y="4983480"/>
+            <a:ext cx="10725912" cy="0"/>
+          </a:xfrm>
+          <a:prstGeom prst="line">
+            <a:avLst/>
+          </a:prstGeom>
+          <a:noFill/>
+          <a:ln w="3810">
+            <a:solidFill>
+              <a:srgbClr val="E0E0E0"/>
+            </a:solidFill>
+            <a:prstDash val="solid"/>
+          </a:ln>
+        </p:spPr>
+      </p:sp>
+    </p:spTree>
+  </p:cSld>
+  <p:clrMapOvr>
+    <a:masterClrMapping/>
+  </p:clrMapOvr>
+</p:sld>
+</file>
+
+<file path=ppt/slides/slide13.xml><?xml version="1.0" encoding="utf-8"?>
+<p:sld xmlns:a="http://schemas.openxmlformats.org/drawingml/2006/main" xmlns:r="http://schemas.openxmlformats.org/officeDocument/2006/relationships" xmlns:p="http://schemas.openxmlformats.org/presentationml/2006/main">
+  <p:cSld name="Slide 13">
+    <p:spTree>
+      <p:nvGrpSpPr>
+        <p:cNvPr id="1" name=""/>
+        <p:cNvGrpSpPr/>
+        <p:nvPr/>
+      </p:nvGrpSpPr>
+      <p:grpSpPr>
+        <a:xfrm>
+          <a:off x="0" y="0"/>
+          <a:ext cx="0" cy="0"/>
+          <a:chOff x="0" y="0"/>
+          <a:chExt cx="0" cy="0"/>
+        </a:xfrm>
+      </p:grpSpPr>
+      <p:sp>
+        <p:nvSpPr>
+          <p:cNvPr id="2" name="Text 0"/>
+          <p:cNvSpPr/>
+          <p:nvPr/>
+        </p:nvSpPr>
+        <p:spPr>
+          <a:xfrm>
+            <a:off x="731520" y="228600"/>
+            <a:ext cx="3657600" cy="228600"/>
+          </a:xfrm>
+          <a:prstGeom prst="rect">
+            <a:avLst/>
+          </a:prstGeom>
+          <a:noFill/>
+          <a:ln/>
+        </p:spPr>
+        <p:txBody>
+          <a:bodyPr wrap="square" rtlCol="0" anchor="ctr"/>
+          <a:lstStyle/>
+          <a:p>
+            <a:pPr indent="0" marL="0">
+              <a:buNone/>
+            </a:pPr>
+            <a:r>
+              <a:rPr lang="en-US" sz="700" b="1" dirty="0">
+                <a:solidFill>
+                  <a:srgbClr val="999999"/>
+                </a:solidFill>
+                <a:latin typeface="HarmonyOS Sans SC" pitchFamily="34" charset="0"/>
+                <a:ea typeface="HarmonyOS Sans SC" pitchFamily="34" charset="-122"/>
+                <a:cs typeface="HarmonyOS Sans SC" pitchFamily="34" charset="-120"/>
+              </a:rPr>
+              <a:t>SEMICONDUCTOR WEEKLY</a:t>
+            </a:r>
+            <a:endParaRPr lang="en-US" sz="700" dirty="0"/>
+          </a:p>
+        </p:txBody>
+      </p:sp>
+      <p:sp>
+        <p:nvSpPr>
+          <p:cNvPr id="3" name="Text 1"/>
+          <p:cNvSpPr/>
+          <p:nvPr/>
+        </p:nvSpPr>
+        <p:spPr>
+          <a:xfrm>
+            <a:off x="8714232" y="228600"/>
+            <a:ext cx="2743200" cy="228600"/>
+          </a:xfrm>
+          <a:prstGeom prst="rect">
+            <a:avLst/>
+          </a:prstGeom>
+          <a:noFill/>
+          <a:ln/>
+        </p:spPr>
+        <p:txBody>
+          <a:bodyPr wrap="square" rtlCol="0" anchor="ctr"/>
+          <a:lstStyle/>
+          <a:p>
+            <a:pPr algn="r" indent="0" marL="0">
+              <a:buNone/>
+            </a:pPr>
+            <a:r>
+              <a:rPr lang="en-US" sz="700" dirty="0">
+                <a:solidFill>
+                  <a:srgbClr val="999999"/>
+                </a:solidFill>
+                <a:latin typeface="JetBrains Mono" pitchFamily="34" charset="0"/>
+                <a:ea typeface="JetBrains Mono" pitchFamily="34" charset="-122"/>
+                <a:cs typeface="JetBrains Mono" pitchFamily="34" charset="-120"/>
+              </a:rPr>
+              <a:t>2026.04.07 — 04.09</a:t>
+            </a:r>
+            <a:endParaRPr lang="en-US" sz="700" dirty="0"/>
+          </a:p>
+        </p:txBody>
+      </p:sp>
+      <p:sp>
+        <p:nvSpPr>
+          <p:cNvPr id="4" name="Shape 2"/>
+          <p:cNvSpPr/>
+          <p:nvPr/>
+        </p:nvSpPr>
+        <p:spPr>
+          <a:xfrm>
+            <a:off x="731520" y="475488"/>
+            <a:ext cx="10725912" cy="0"/>
+          </a:xfrm>
+          <a:prstGeom prst="line">
+            <a:avLst/>
+          </a:prstGeom>
+          <a:noFill/>
+          <a:ln w="6350">
+            <a:solidFill>
+              <a:srgbClr val="141414"/>
+            </a:solidFill>
+            <a:prstDash val="solid"/>
+          </a:ln>
+        </p:spPr>
+      </p:sp>
+      <p:sp>
+        <p:nvSpPr>
+          <p:cNvPr id="5" name="Shape 3"/>
+          <p:cNvSpPr/>
+          <p:nvPr/>
+        </p:nvSpPr>
+        <p:spPr>
+          <a:xfrm>
+            <a:off x="731520" y="6473952"/>
+            <a:ext cx="10725912" cy="0"/>
+          </a:xfrm>
+          <a:prstGeom prst="line">
+            <a:avLst/>
+          </a:prstGeom>
+          <a:noFill/>
+          <a:ln w="3810">
+            <a:solidFill>
+              <a:srgbClr val="E0E0E0"/>
+            </a:solidFill>
+            <a:prstDash val="solid"/>
+          </a:ln>
+        </p:spPr>
+      </p:sp>
+      <p:sp>
+        <p:nvSpPr>
+          <p:cNvPr id="6" name="Text 4"/>
+          <p:cNvSpPr/>
+          <p:nvPr/>
+        </p:nvSpPr>
+        <p:spPr>
+          <a:xfrm>
+            <a:off x="731520" y="6510528"/>
+            <a:ext cx="1828800" cy="182880"/>
+          </a:xfrm>
+          <a:prstGeom prst="rect">
+            <a:avLst/>
+          </a:prstGeom>
+          <a:noFill/>
+          <a:ln/>
+        </p:spPr>
+        <p:txBody>
+          <a:bodyPr wrap="square" rtlCol="0" anchor="ctr"/>
+          <a:lstStyle/>
+          <a:p>
+            <a:pPr indent="0" marL="0">
+              <a:buNone/>
+            </a:pPr>
+            <a:r>
+              <a:rPr lang="en-US" sz="650" dirty="0">
+                <a:solidFill>
+                  <a:srgbClr val="999999"/>
+                </a:solidFill>
+                <a:latin typeface="JetBrains Mono" pitchFamily="34" charset="0"/>
+                <a:ea typeface="JetBrains Mono" pitchFamily="34" charset="-122"/>
+                <a:cs typeface="JetBrains Mono" pitchFamily="34" charset="-120"/>
+              </a:rPr>
+              <a:t>Confidential</a:t>
+            </a:r>
+            <a:endParaRPr lang="en-US" sz="650" dirty="0"/>
+          </a:p>
+        </p:txBody>
+      </p:sp>
+      <p:sp>
+        <p:nvSpPr>
+          <p:cNvPr id="7" name="Text 5"/>
+          <p:cNvSpPr/>
+          <p:nvPr/>
+        </p:nvSpPr>
+        <p:spPr>
+          <a:xfrm>
+            <a:off x="10543032" y="6510528"/>
+            <a:ext cx="914400" cy="182880"/>
+          </a:xfrm>
+          <a:prstGeom prst="rect">
+            <a:avLst/>
+          </a:prstGeom>
+          <a:noFill/>
+          <a:ln/>
+        </p:spPr>
+        <p:txBody>
+          <a:bodyPr wrap="square" rtlCol="0" anchor="ctr"/>
+          <a:lstStyle/>
+          <a:p>
+            <a:pPr algn="r" indent="0" marL="0">
+              <a:buNone/>
+            </a:pPr>
+            <a:r>
+              <a:rPr lang="en-US" sz="650" dirty="0">
+                <a:solidFill>
+                  <a:srgbClr val="999999"/>
+                </a:solidFill>
+                <a:latin typeface="JetBrains Mono" pitchFamily="34" charset="0"/>
+                <a:ea typeface="JetBrains Mono" pitchFamily="34" charset="-122"/>
+                <a:cs typeface="JetBrains Mono" pitchFamily="34" charset="-120"/>
+              </a:rPr>
+              <a:t>13 / 13</a:t>
             </a:r>
             <a:endParaRPr lang="en-US" sz="650" dirty="0"/>
           </a:p>
@@ -5719,7 +6568,7 @@
                 <a:ea typeface="JetBrains Mono" pitchFamily="34" charset="-122"/>
                 <a:cs typeface="JetBrains Mono" pitchFamily="34" charset="-120"/>
               </a:rPr>
-              <a:t>2 / 12</a:t>
+              <a:t>2 / 13</a:t>
             </a:r>
             <a:endParaRPr lang="en-US" sz="650" dirty="0"/>
           </a:p>
@@ -6888,7 +7737,7 @@
                 <a:ea typeface="JetBrains Mono" pitchFamily="34" charset="-122"/>
                 <a:cs typeface="JetBrains Mono" pitchFamily="34" charset="-120"/>
               </a:rPr>
-              <a:t>3 / 12</a:t>
+              <a:t>3 / 13</a:t>
             </a:r>
             <a:endParaRPr lang="en-US" sz="650" dirty="0"/>
           </a:p>
@@ -8269,7 +9118,7 @@
                 <a:ea typeface="JetBrains Mono" pitchFamily="34" charset="-122"/>
                 <a:cs typeface="JetBrains Mono" pitchFamily="34" charset="-120"/>
               </a:rPr>
-              <a:t>4 / 12</a:t>
+              <a:t>4 / 13</a:t>
             </a:r>
             <a:endParaRPr lang="en-US" sz="650" dirty="0"/>
           </a:p>
@@ -9329,7 +10178,7 @@
                 <a:ea typeface="JetBrains Mono" pitchFamily="34" charset="-122"/>
                 <a:cs typeface="JetBrains Mono" pitchFamily="34" charset="-120"/>
               </a:rPr>
-              <a:t>5 / 12</a:t>
+              <a:t>5 / 13</a:t>
             </a:r>
             <a:endParaRPr lang="en-US" sz="650" dirty="0"/>
           </a:p>
@@ -10225,7 +11074,7 @@
                 <a:ea typeface="JetBrains Mono" pitchFamily="34" charset="-122"/>
                 <a:cs typeface="JetBrains Mono" pitchFamily="34" charset="-120"/>
               </a:rPr>
-              <a:t>6 / 12</a:t>
+              <a:t>6 / 13</a:t>
             </a:r>
             <a:endParaRPr lang="en-US" sz="650" dirty="0"/>
           </a:p>
@@ -10881,7 +11730,7 @@
                 <a:ea typeface="JetBrains Mono" pitchFamily="34" charset="-122"/>
                 <a:cs typeface="JetBrains Mono" pitchFamily="34" charset="-120"/>
               </a:rPr>
-              <a:t>7 / 12</a:t>
+              <a:t>7 / 13</a:t>
             </a:r>
             <a:endParaRPr lang="en-US" sz="650" dirty="0"/>
           </a:p>
@@ -12063,7 +12912,7 @@
                 <a:ea typeface="JetBrains Mono" pitchFamily="34" charset="-122"/>
                 <a:cs typeface="JetBrains Mono" pitchFamily="34" charset="-120"/>
               </a:rPr>
-              <a:t>8 / 12</a:t>
+              <a:t>8 / 13</a:t>
             </a:r>
             <a:endParaRPr lang="en-US" sz="650" dirty="0"/>
           </a:p>
@@ -12823,7 +13672,7 @@
                 <a:ea typeface="JetBrains Mono" pitchFamily="34" charset="-122"/>
                 <a:cs typeface="JetBrains Mono" pitchFamily="34" charset="-120"/>
               </a:rPr>
-              <a:t>9 / 12</a:t>
+              <a:t>9 / 13</a:t>
             </a:r>
             <a:endParaRPr lang="en-US" sz="650" dirty="0"/>
           </a:p>

</xml_diff>